<commit_message>
Rebuild PPT with national-level depth: 12-row comparison, 13-row tech stack, all 6 AI capabilities, quantified impact, risk mitigations, peer-reviewed references
</commit_message>
<xml_diff>
--- a/SYNAPSE_final.pptx
+++ b/SYNAPSE_final.pptx
@@ -6127,49 +6127,12 @@
           <a:p>
             <a:pPr algn="ctr"/>
             <a:r>
-              <a:rPr sz="1350" b="0">
-                <a:solidFill>
-                  <a:srgbClr val="262626"/>
-                </a:solidFill>
-                <a:latin typeface="Arial"/>
-              </a:rPr>
-              <a:t>For Oil India EPC planners who lose </a:t>
-            </a:r>
-            <a:r>
-              <a:rPr sz="1350" b="1">
-                <a:solidFill>
-                  <a:srgbClr val="1F4E79"/>
-                </a:solidFill>
-                <a:latin typeface="Arial"/>
-              </a:rPr>
-              <a:t>3–5 hrs/day</a:t>
-            </a:r>
-            <a:r>
-              <a:rPr sz="1350" b="0">
-                <a:solidFill>
-                  <a:srgbClr val="262626"/>
-                </a:solidFill>
-                <a:latin typeface="Arial"/>
-              </a:rPr>
-              <a:t> to manual reconciliation, SYNAPSE links free-text field reports to Primavera P6 activities in </a:t>
-            </a:r>
-            <a:r>
-              <a:rPr sz="1350" b="1">
-                <a:solidFill>
-                  <a:srgbClr val="1F4E79"/>
-                </a:solidFill>
-                <a:latin typeface="Arial"/>
-              </a:rPr>
-              <a:t>near real-time</a:t>
-            </a:r>
-            <a:r>
-              <a:rPr sz="1350" b="0">
-                <a:solidFill>
-                  <a:srgbClr val="262626"/>
-                </a:solidFill>
-                <a:latin typeface="Arial"/>
-              </a:rPr>
-              <a:t> — unlike P6's fully manual entry.</a:t>
+              <a:rPr sz="1350" b="1"/>
+              <a:t>The problem: </a:t>
+            </a:r>
+            <a:r>
+              <a:rPr sz="1350"/>
+              <a:t>EPC planners at Oil India spend 3–5 hrs/day manually matching 50–200 daily field reports to Primavera P6 schedules. Updates lag 24–72 hrs. Mis-link rate: ~10–15%. When projects close, all execution knowledge is lost.</a:t>
             </a:r>
           </a:p>
         </p:txBody>
@@ -6197,13 +6160,8 @@
           <a:lstStyle/>
           <a:p>
             <a:r>
-              <a:rPr b="1" sz="1500">
-                <a:solidFill>
-                  <a:srgbClr val="1F4E79"/>
-                </a:solidFill>
-                <a:latin typeface="Arial"/>
-              </a:rPr>
-              <a:t>How SYNAPSE works</a:t>
+              <a:rPr sz="1500" b="1"/>
+              <a:t>How SYNAPSE solves it — end to end</a:t>
             </a:r>
           </a:p>
         </p:txBody>
@@ -6240,41 +6198,39 @@
               <a:buFont typeface="Arial"/>
               <a:buChar char="•"/>
             </a:pPr>
-          </a:p>
-          <a:p>
-            <a:r>
-              <a:rPr sz="1200"/>
-              <a:t>Reads DPRs (text/PDF/CSV), supervisor voice &amp; typed messages → extracts structured execution events</a:t>
-            </a:r>
-          </a:p>
-          <a:p>
-            <a:r>
-              <a:rPr sz="1200"/>
-              <a:t>7-layer matching: semantic (MiniLM) + asset ID + discipline + location + WBS + temporal + dependency</a:t>
-            </a:r>
-          </a:p>
-          <a:p>
-            <a:r>
-              <a:rPr sz="1200"/>
-              <a:t>Confidence router: ≥0.85 auto-link · 0.65–0.85 RL-ranked review · &lt;0.65 agentic clarification</a:t>
-            </a:r>
-          </a:p>
-          <a:p>
-            <a:r>
-              <a:rPr sz="1200"/>
-              <a:t>RL Priority Queue re-orders review items by real-world impact — learns from every decision</a:t>
-            </a:r>
-          </a:p>
-          <a:p>
-            <a:r>
-              <a:rPr sz="1200"/>
-              <a:t>Cascade Impact Prediction: BFS through successor graph shows downstream slip before reviewer decides</a:t>
-            </a:r>
-          </a:p>
-          <a:p>
-            <a:r>
-              <a:rPr sz="1200"/>
-              <a:t>Cross-source conflict detection catches contradictory reports; state regression flags data quality issues</a:t>
+            <a:r>
+              <a:rPr sz="1200" b="0"/>
+              <a:t>① Supervisor speaks or types a field report → SYNAPSE extracts structured execution events (LLM + rule-based hybrid)</a:t>
+            </a:r>
+          </a:p>
+          <a:p>
+            <a:r>
+              <a:rPr sz="1200" b="0"/>
+              <a:t>② 7-layer AI matching engine links each event to the correct P6 activity — semantic, identifier, discipline, location, WBS, temporal, dependency</a:t>
+            </a:r>
+          </a:p>
+          <a:p>
+            <a:r>
+              <a:rPr sz="1200" b="0"/>
+              <a:t>③ Confidence-gated routing: ≥85% auto-linked · 65–85% RL-prioritised review queue · &lt;65% agentic clarification asks one targeted question</a:t>
+            </a:r>
+          </a:p>
+          <a:p>
+            <a:r>
+              <a:rPr sz="1200" b="0"/>
+              <a:t>④ RL Priority Queue reorders review items by downstream project impact — learns from every reviewer decision via online gradient descent</a:t>
+            </a:r>
+          </a:p>
+          <a:p>
+            <a:r>
+              <a:rPr sz="1200" b="0"/>
+              <a:t>⑤ Cascade Impact Engine (BFS) shows how confirming a delay propagates through the successor graph before the reviewer decides</a:t>
+            </a:r>
+          </a:p>
+          <a:p>
+            <a:r>
+              <a:rPr sz="1200" b="0"/>
+              <a:t>⑥ Knowledge Base retains delay patterns, causes &amp; productivity across projects — powers risk alerts on future activities</a:t>
             </a:r>
           </a:p>
         </p:txBody>
@@ -6289,7 +6245,7 @@
         </p:nvGraphicFramePr>
         <p:xfrm>
           <a:off x="6080760" y="2487168"/>
-          <a:ext cx="5742431" cy="3793200"/>
+          <a:ext cx="5742431" cy="4753200"/>
         </p:xfrm>
         <a:graphic>
           <a:graphicData uri="http://schemas.openxmlformats.org/drawingml/2006/table">
@@ -6309,14 +6265,8 @@
                     <a:bodyPr wrap="square"/>
                     <a:lstStyle/>
                     <a:p>
-                      <a:pPr algn="l"/>
                       <a:r>
-                        <a:rPr sz="1100" b="1">
-                          <a:solidFill>
-                            <a:srgbClr val="3B3B3B"/>
-                          </a:solidFill>
-                          <a:latin typeface="Arial"/>
-                        </a:rPr>
+                        <a:rPr sz="950" b="1"/>
                         <a:t>Capability</a:t>
                       </a:r>
                     </a:p>
@@ -6332,15 +6282,9 @@
                     <a:bodyPr wrap="square"/>
                     <a:lstStyle/>
                     <a:p>
-                      <a:pPr algn="ctr"/>
                       <a:r>
-                        <a:rPr sz="1100" b="1">
-                          <a:solidFill>
-                            <a:srgbClr val="3B3B3B"/>
-                          </a:solidFill>
-                          <a:latin typeface="Arial"/>
-                        </a:rPr>
-                        <a:t>P6</a:t>
+                        <a:rPr sz="950" b="1"/>
+                        <a:t>Primavera P6</a:t>
                       </a:r>
                     </a:p>
                   </a:txBody>
@@ -6355,14 +6299,8 @@
                     <a:bodyPr wrap="square"/>
                     <a:lstStyle/>
                     <a:p>
-                      <a:pPr algn="ctr"/>
                       <a:r>
-                        <a:rPr sz="1100" b="1">
-                          <a:solidFill>
-                            <a:srgbClr val="3B3B3B"/>
-                          </a:solidFill>
-                          <a:latin typeface="Arial"/>
-                        </a:rPr>
+                        <a:rPr sz="950" b="1"/>
                         <a:t>MS Project</a:t>
                       </a:r>
                     </a:p>
@@ -6378,14 +6316,8 @@
                     <a:bodyPr wrap="square"/>
                     <a:lstStyle/>
                     <a:p>
-                      <a:pPr algn="ctr"/>
                       <a:r>
-                        <a:rPr sz="1100" b="1">
-                          <a:solidFill>
-                            <a:srgbClr val="FFFFFF"/>
-                          </a:solidFill>
-                          <a:latin typeface="Arial"/>
-                        </a:rPr>
+                        <a:rPr sz="950" b="1"/>
                         <a:t>SYNAPSE</a:t>
                       </a:r>
                     </a:p>
@@ -6403,15 +6335,9 @@
                     <a:bodyPr wrap="square"/>
                     <a:lstStyle/>
                     <a:p>
-                      <a:pPr algn="l"/>
                       <a:r>
-                        <a:rPr sz="1050" b="0">
-                          <a:solidFill>
-                            <a:srgbClr val="262626"/>
-                          </a:solidFill>
-                          <a:latin typeface="Arial"/>
-                        </a:rPr>
-                        <a:t>Reads free-text DPRs</a:t>
+                        <a:rPr sz="900"/>
+                        <a:t>Reads free-text / voice field reports</a:t>
                       </a:r>
                     </a:p>
                   </a:txBody>
@@ -6426,15 +6352,13 @@
                     <a:bodyPr wrap="square"/>
                     <a:lstStyle/>
                     <a:p>
-                      <a:pPr algn="ctr"/>
                       <a:r>
-                        <a:rPr sz="1100" b="0">
+                        <a:rPr sz="900">
                           <a:solidFill>
-                            <a:srgbClr val="262626"/>
+                            <a:srgbClr val="F87171"/>
                           </a:solidFill>
-                          <a:latin typeface="Arial"/>
                         </a:rPr>
-                        <a:t>No</a:t>
+                        <a:t>✗</a:t>
                       </a:r>
                     </a:p>
                   </a:txBody>
@@ -6449,15 +6373,13 @@
                     <a:bodyPr wrap="square"/>
                     <a:lstStyle/>
                     <a:p>
-                      <a:pPr algn="ctr"/>
                       <a:r>
-                        <a:rPr sz="1100" b="0">
+                        <a:rPr sz="900">
                           <a:solidFill>
-                            <a:srgbClr val="262626"/>
+                            <a:srgbClr val="F87171"/>
                           </a:solidFill>
-                          <a:latin typeface="Arial"/>
                         </a:rPr>
-                        <a:t>No</a:t>
+                        <a:t>✗</a:t>
                       </a:r>
                     </a:p>
                   </a:txBody>
@@ -6472,15 +6394,13 @@
                     <a:bodyPr wrap="square"/>
                     <a:lstStyle/>
                     <a:p>
-                      <a:pPr algn="ctr"/>
                       <a:r>
-                        <a:rPr sz="1100" b="1">
+                        <a:rPr sz="900">
                           <a:solidFill>
-                            <a:srgbClr val="2E5D1F"/>
+                            <a:srgbClr val="34D399"/>
                           </a:solidFill>
-                          <a:latin typeface="Arial"/>
                         </a:rPr>
-                        <a:t>Yes</a:t>
+                        <a:t>✓  Hybrid LLM + rule extraction</a:t>
                       </a:r>
                     </a:p>
                   </a:txBody>
@@ -6497,15 +6417,9 @@
                     <a:bodyPr wrap="square"/>
                     <a:lstStyle/>
                     <a:p>
-                      <a:pPr algn="l"/>
                       <a:r>
-                        <a:rPr sz="1050" b="0">
-                          <a:solidFill>
-                            <a:srgbClr val="262626"/>
-                          </a:solidFill>
-                          <a:latin typeface="Arial"/>
-                        </a:rPr>
-                        <a:t>Auto-links to schedule</a:t>
+                        <a:rPr sz="900"/>
+                        <a:t>Auto-links events to schedule activities</a:t>
                       </a:r>
                     </a:p>
                   </a:txBody>
@@ -6520,15 +6434,13 @@
                     <a:bodyPr wrap="square"/>
                     <a:lstStyle/>
                     <a:p>
-                      <a:pPr algn="ctr"/>
                       <a:r>
-                        <a:rPr sz="1100" b="0">
+                        <a:rPr sz="900">
                           <a:solidFill>
-                            <a:srgbClr val="262626"/>
+                            <a:srgbClr val="F87171"/>
                           </a:solidFill>
-                          <a:latin typeface="Arial"/>
                         </a:rPr>
-                        <a:t>No</a:t>
+                        <a:t>✗</a:t>
                       </a:r>
                     </a:p>
                   </a:txBody>
@@ -6543,15 +6455,13 @@
                     <a:bodyPr wrap="square"/>
                     <a:lstStyle/>
                     <a:p>
-                      <a:pPr algn="ctr"/>
                       <a:r>
-                        <a:rPr sz="1100" b="0">
+                        <a:rPr sz="900">
                           <a:solidFill>
-                            <a:srgbClr val="262626"/>
+                            <a:srgbClr val="F87171"/>
                           </a:solidFill>
-                          <a:latin typeface="Arial"/>
                         </a:rPr>
-                        <a:t>No</a:t>
+                        <a:t>✗</a:t>
                       </a:r>
                     </a:p>
                   </a:txBody>
@@ -6566,15 +6476,13 @@
                     <a:bodyPr wrap="square"/>
                     <a:lstStyle/>
                     <a:p>
-                      <a:pPr algn="ctr"/>
                       <a:r>
-                        <a:rPr sz="1100" b="1">
+                        <a:rPr sz="900">
                           <a:solidFill>
-                            <a:srgbClr val="2E5D1F"/>
+                            <a:srgbClr val="34D399"/>
                           </a:solidFill>
-                          <a:latin typeface="Arial"/>
                         </a:rPr>
-                        <a:t>Yes</a:t>
+                        <a:t>✓  7-layer semantic matching</a:t>
                       </a:r>
                     </a:p>
                   </a:txBody>
@@ -6591,15 +6499,9 @@
                     <a:bodyPr wrap="square"/>
                     <a:lstStyle/>
                     <a:p>
-                      <a:pPr algn="l"/>
                       <a:r>
-                        <a:rPr sz="1050" b="0">
-                          <a:solidFill>
-                            <a:srgbClr val="262626"/>
-                          </a:solidFill>
-                          <a:latin typeface="Arial"/>
-                        </a:rPr>
-                        <a:t>Handles ambiguity (Agentic)</a:t>
+                        <a:rPr sz="900"/>
+                        <a:t>Resolves ambiguity at source (Agentic AI)</a:t>
                       </a:r>
                     </a:p>
                   </a:txBody>
@@ -6614,15 +6516,13 @@
                     <a:bodyPr wrap="square"/>
                     <a:lstStyle/>
                     <a:p>
-                      <a:pPr algn="ctr"/>
                       <a:r>
-                        <a:rPr sz="1100" b="0">
+                        <a:rPr sz="900">
                           <a:solidFill>
-                            <a:srgbClr val="262626"/>
+                            <a:srgbClr val="F87171"/>
                           </a:solidFill>
-                          <a:latin typeface="Arial"/>
                         </a:rPr>
-                        <a:t>No</a:t>
+                        <a:t>✗</a:t>
                       </a:r>
                     </a:p>
                   </a:txBody>
@@ -6637,15 +6537,13 @@
                     <a:bodyPr wrap="square"/>
                     <a:lstStyle/>
                     <a:p>
-                      <a:pPr algn="ctr"/>
                       <a:r>
-                        <a:rPr sz="1100" b="0">
+                        <a:rPr sz="900">
                           <a:solidFill>
-                            <a:srgbClr val="262626"/>
+                            <a:srgbClr val="F87171"/>
                           </a:solidFill>
-                          <a:latin typeface="Arial"/>
                         </a:rPr>
-                        <a:t>No</a:t>
+                        <a:t>✗</a:t>
                       </a:r>
                     </a:p>
                   </a:txBody>
@@ -6660,15 +6558,13 @@
                     <a:bodyPr wrap="square"/>
                     <a:lstStyle/>
                     <a:p>
-                      <a:pPr algn="ctr"/>
                       <a:r>
-                        <a:rPr sz="1100" b="1">
+                        <a:rPr sz="900">
                           <a:solidFill>
-                            <a:srgbClr val="2E5D1F"/>
+                            <a:srgbClr val="34D399"/>
                           </a:solidFill>
-                          <a:latin typeface="Arial"/>
                         </a:rPr>
-                        <a:t>Yes</a:t>
+                        <a:t>✓  Clarification loop</a:t>
                       </a:r>
                     </a:p>
                   </a:txBody>
@@ -6685,15 +6581,9 @@
                     <a:bodyPr wrap="square"/>
                     <a:lstStyle/>
                     <a:p>
-                      <a:pPr algn="l"/>
                       <a:r>
-                        <a:rPr sz="1050" b="0">
-                          <a:solidFill>
-                            <a:srgbClr val="262626"/>
-                          </a:solidFill>
-                          <a:latin typeface="Arial"/>
-                        </a:rPr>
-                        <a:t>Learns from feedback (Active Learning)</a:t>
+                        <a:rPr sz="900"/>
+                        <a:t>Learns from reviewer corrections</a:t>
                       </a:r>
                     </a:p>
                   </a:txBody>
@@ -6708,15 +6598,13 @@
                     <a:bodyPr wrap="square"/>
                     <a:lstStyle/>
                     <a:p>
-                      <a:pPr algn="ctr"/>
                       <a:r>
-                        <a:rPr sz="1100" b="0">
+                        <a:rPr sz="900">
                           <a:solidFill>
-                            <a:srgbClr val="262626"/>
+                            <a:srgbClr val="F87171"/>
                           </a:solidFill>
-                          <a:latin typeface="Arial"/>
                         </a:rPr>
-                        <a:t>No</a:t>
+                        <a:t>✗</a:t>
                       </a:r>
                     </a:p>
                   </a:txBody>
@@ -6731,15 +6619,13 @@
                     <a:bodyPr wrap="square"/>
                     <a:lstStyle/>
                     <a:p>
-                      <a:pPr algn="ctr"/>
                       <a:r>
-                        <a:rPr sz="1100" b="0">
+                        <a:rPr sz="900">
                           <a:solidFill>
-                            <a:srgbClr val="262626"/>
+                            <a:srgbClr val="F87171"/>
                           </a:solidFill>
-                          <a:latin typeface="Arial"/>
                         </a:rPr>
-                        <a:t>No</a:t>
+                        <a:t>✗</a:t>
                       </a:r>
                     </a:p>
                   </a:txBody>
@@ -6754,15 +6640,13 @@
                     <a:bodyPr wrap="square"/>
                     <a:lstStyle/>
                     <a:p>
-                      <a:pPr algn="ctr"/>
                       <a:r>
-                        <a:rPr sz="1100" b="1">
+                        <a:rPr sz="900">
                           <a:solidFill>
-                            <a:srgbClr val="2E5D1F"/>
+                            <a:srgbClr val="34D399"/>
                           </a:solidFill>
-                          <a:latin typeface="Arial"/>
                         </a:rPr>
-                        <a:t>Yes</a:t>
+                        <a:t>✓  Active Learning feedback</a:t>
                       </a:r>
                     </a:p>
                   </a:txBody>
@@ -6779,15 +6663,9 @@
                     <a:bodyPr wrap="square"/>
                     <a:lstStyle/>
                     <a:p>
-                      <a:pPr algn="l"/>
                       <a:r>
-                        <a:rPr sz="1050" b="0">
-                          <a:solidFill>
-                            <a:srgbClr val="262626"/>
-                          </a:solidFill>
-                          <a:latin typeface="Arial"/>
-                        </a:rPr>
-                        <a:t>Delay-risk prediction</a:t>
+                        <a:rPr sz="900"/>
+                        <a:t>Predicts downstream cascade impact</a:t>
                       </a:r>
                     </a:p>
                   </a:txBody>
@@ -6802,15 +6680,13 @@
                     <a:bodyPr wrap="square"/>
                     <a:lstStyle/>
                     <a:p>
-                      <a:pPr algn="ctr"/>
                       <a:r>
-                        <a:rPr sz="1100" b="0">
+                        <a:rPr sz="900">
                           <a:solidFill>
-                            <a:srgbClr val="262626"/>
+                            <a:srgbClr val="F87171"/>
                           </a:solidFill>
-                          <a:latin typeface="Arial"/>
                         </a:rPr>
-                        <a:t>No</a:t>
+                        <a:t>✗</a:t>
                       </a:r>
                     </a:p>
                   </a:txBody>
@@ -6825,15 +6701,13 @@
                     <a:bodyPr wrap="square"/>
                     <a:lstStyle/>
                     <a:p>
-                      <a:pPr algn="ctr"/>
                       <a:r>
-                        <a:rPr sz="1100" b="0">
+                        <a:rPr sz="900">
                           <a:solidFill>
-                            <a:srgbClr val="262626"/>
+                            <a:srgbClr val="F87171"/>
                           </a:solidFill>
-                          <a:latin typeface="Arial"/>
                         </a:rPr>
-                        <a:t>No</a:t>
+                        <a:t>✗</a:t>
                       </a:r>
                     </a:p>
                   </a:txBody>
@@ -6848,15 +6722,13 @@
                     <a:bodyPr wrap="square"/>
                     <a:lstStyle/>
                     <a:p>
-                      <a:pPr algn="ctr"/>
                       <a:r>
-                        <a:rPr sz="1100" b="1">
+                        <a:rPr sz="900">
                           <a:solidFill>
-                            <a:srgbClr val="2E5D1F"/>
+                            <a:srgbClr val="34D399"/>
                           </a:solidFill>
-                          <a:latin typeface="Arial"/>
                         </a:rPr>
-                        <a:t>Yes</a:t>
+                        <a:t>✓  BFS successor traversal</a:t>
                       </a:r>
                     </a:p>
                   </a:txBody>
@@ -7113,6 +6985,252 @@
                   </a:tcPr>
                 </a:tc>
               </a:tr>
+              <a:tr h="320000">
+                <a:tc>
+                  <a:txBody>
+                    <a:bodyPr wrap="square"/>
+                    <a:lstStyle/>
+                    <a:p>
+                      <a:r>
+                        <a:rPr sz="900" b="1"/>
+                        <a:t>RL-prioritised review queue</a:t>
+                      </a:r>
+                    </a:p>
+                  </a:txBody>
+                  <a:tcPr marL="45720" marR="45720" marT="18288" marB="18288" anchor="ctr">
+                    <a:solidFill>
+                      <a:srgbClr val="FFFFFF"/>
+                    </a:solidFill>
+                  </a:tcPr>
+                </a:tc>
+                <a:tc>
+                  <a:txBody>
+                    <a:bodyPr wrap="square"/>
+                    <a:lstStyle/>
+                    <a:p>
+                      <a:r>
+                        <a:rPr sz="900">
+                          <a:solidFill>
+                            <a:srgbClr val="F87171"/>
+                          </a:solidFill>
+                        </a:rPr>
+                        <a:t>✗</a:t>
+                      </a:r>
+                    </a:p>
+                  </a:txBody>
+                  <a:tcPr marL="45720" marR="45720" marT="18288" marB="18288" anchor="ctr">
+                    <a:solidFill>
+                      <a:srgbClr val="FFFFFF"/>
+                    </a:solidFill>
+                  </a:tcPr>
+                </a:tc>
+                <a:tc>
+                  <a:txBody>
+                    <a:bodyPr wrap="square"/>
+                    <a:lstStyle/>
+                    <a:p>
+                      <a:r>
+                        <a:rPr sz="900">
+                          <a:solidFill>
+                            <a:srgbClr val="F87171"/>
+                          </a:solidFill>
+                        </a:rPr>
+                        <a:t>✗</a:t>
+                      </a:r>
+                    </a:p>
+                  </a:txBody>
+                  <a:tcPr marL="45720" marR="45720" marT="18288" marB="18288" anchor="ctr">
+                    <a:solidFill>
+                      <a:srgbClr val="FFFFFF"/>
+                    </a:solidFill>
+                  </a:tcPr>
+                </a:tc>
+                <a:tc>
+                  <a:txBody>
+                    <a:bodyPr wrap="square"/>
+                    <a:lstStyle/>
+                    <a:p>
+                      <a:r>
+                        <a:rPr sz="900">
+                          <a:solidFill>
+                            <a:srgbClr val="34D399"/>
+                          </a:solidFill>
+                        </a:rPr>
+                        <a:t>✓  Contextual bandit, online learning</a:t>
+                      </a:r>
+                    </a:p>
+                  </a:txBody>
+                  <a:tcPr marL="45720" marR="45720" marT="18288" marB="18288" anchor="ctr">
+                    <a:solidFill>
+                      <a:srgbClr val="E2EFDA"/>
+                    </a:solidFill>
+                  </a:tcPr>
+                </a:tc>
+              </a:tr>
+              <a:tr h="320000">
+                <a:tc>
+                  <a:txBody>
+                    <a:bodyPr wrap="square"/>
+                    <a:lstStyle/>
+                    <a:p>
+                      <a:r>
+                        <a:rPr sz="900" b="1"/>
+                        <a:t>Cross-source conflict detection</a:t>
+                      </a:r>
+                    </a:p>
+                  </a:txBody>
+                  <a:tcPr marL="45720" marR="45720" marT="18288" marB="18288" anchor="ctr">
+                    <a:solidFill>
+                      <a:srgbClr val="FFFFFF"/>
+                    </a:solidFill>
+                  </a:tcPr>
+                </a:tc>
+                <a:tc>
+                  <a:txBody>
+                    <a:bodyPr wrap="square"/>
+                    <a:lstStyle/>
+                    <a:p>
+                      <a:r>
+                        <a:rPr sz="900">
+                          <a:solidFill>
+                            <a:srgbClr val="F87171"/>
+                          </a:solidFill>
+                        </a:rPr>
+                        <a:t>✗</a:t>
+                      </a:r>
+                    </a:p>
+                  </a:txBody>
+                  <a:tcPr marL="45720" marR="45720" marT="18288" marB="18288" anchor="ctr">
+                    <a:solidFill>
+                      <a:srgbClr val="FFFFFF"/>
+                    </a:solidFill>
+                  </a:tcPr>
+                </a:tc>
+                <a:tc>
+                  <a:txBody>
+                    <a:bodyPr wrap="square"/>
+                    <a:lstStyle/>
+                    <a:p>
+                      <a:r>
+                        <a:rPr sz="900">
+                          <a:solidFill>
+                            <a:srgbClr val="F87171"/>
+                          </a:solidFill>
+                        </a:rPr>
+                        <a:t>✗</a:t>
+                      </a:r>
+                    </a:p>
+                  </a:txBody>
+                  <a:tcPr marL="45720" marR="45720" marT="18288" marB="18288" anchor="ctr">
+                    <a:solidFill>
+                      <a:srgbClr val="FFFFFF"/>
+                    </a:solidFill>
+                  </a:tcPr>
+                </a:tc>
+                <a:tc>
+                  <a:txBody>
+                    <a:bodyPr wrap="square"/>
+                    <a:lstStyle/>
+                    <a:p>
+                      <a:r>
+                        <a:rPr sz="900">
+                          <a:solidFill>
+                            <a:srgbClr val="34D399"/>
+                          </a:solidFill>
+                        </a:rPr>
+                        <a:t>✓  State regression flagging</a:t>
+                      </a:r>
+                    </a:p>
+                  </a:txBody>
+                  <a:tcPr marL="45720" marR="45720" marT="18288" marB="18288" anchor="ctr">
+                    <a:solidFill>
+                      <a:srgbClr val="E2EFDA"/>
+                    </a:solidFill>
+                  </a:tcPr>
+                </a:tc>
+              </a:tr>
+              <a:tr h="320000">
+                <a:tc>
+                  <a:txBody>
+                    <a:bodyPr wrap="square"/>
+                    <a:lstStyle/>
+                    <a:p>
+                      <a:r>
+                        <a:rPr sz="900" b="1"/>
+                        <a:t>Historical delay risk intelligence</a:t>
+                      </a:r>
+                    </a:p>
+                  </a:txBody>
+                  <a:tcPr marL="45720" marR="45720" marT="18288" marB="18288" anchor="ctr">
+                    <a:solidFill>
+                      <a:srgbClr val="FFFFFF"/>
+                    </a:solidFill>
+                  </a:tcPr>
+                </a:tc>
+                <a:tc>
+                  <a:txBody>
+                    <a:bodyPr wrap="square"/>
+                    <a:lstStyle/>
+                    <a:p>
+                      <a:r>
+                        <a:rPr sz="900">
+                          <a:solidFill>
+                            <a:srgbClr val="F87171"/>
+                          </a:solidFill>
+                        </a:rPr>
+                        <a:t>✗</a:t>
+                      </a:r>
+                    </a:p>
+                  </a:txBody>
+                  <a:tcPr marL="45720" marR="45720" marT="18288" marB="18288" anchor="ctr">
+                    <a:solidFill>
+                      <a:srgbClr val="FFFFFF"/>
+                    </a:solidFill>
+                  </a:tcPr>
+                </a:tc>
+                <a:tc>
+                  <a:txBody>
+                    <a:bodyPr wrap="square"/>
+                    <a:lstStyle/>
+                    <a:p>
+                      <a:r>
+                        <a:rPr sz="900">
+                          <a:solidFill>
+                            <a:srgbClr val="F87171"/>
+                          </a:solidFill>
+                        </a:rPr>
+                        <a:t>✗</a:t>
+                      </a:r>
+                    </a:p>
+                  </a:txBody>
+                  <a:tcPr marL="45720" marR="45720" marT="18288" marB="18288" anchor="ctr">
+                    <a:solidFill>
+                      <a:srgbClr val="FFFFFF"/>
+                    </a:solidFill>
+                  </a:tcPr>
+                </a:tc>
+                <a:tc>
+                  <a:txBody>
+                    <a:bodyPr wrap="square"/>
+                    <a:lstStyle/>
+                    <a:p>
+                      <a:r>
+                        <a:rPr sz="900">
+                          <a:solidFill>
+                            <a:srgbClr val="34D399"/>
+                          </a:solidFill>
+                        </a:rPr>
+                        <a:t>✓  Institutional memory + NL query</a:t>
+                      </a:r>
+                    </a:p>
+                  </a:txBody>
+                  <a:tcPr marL="45720" marR="45720" marT="18288" marB="18288" anchor="ctr">
+                    <a:solidFill>
+                      <a:srgbClr val="E2EFDA"/>
+                    </a:solidFill>
+                  </a:tcPr>
+                </a:tc>
+              </a:tr>
             </a:tbl>
           </a:graphicData>
         </a:graphic>
@@ -7142,11 +7260,11 @@
             <a:pPr algn="l"/>
             <a:r>
               <a:rPr sz="1250" b="1"/>
-              <a:t>What no other team has:  </a:t>
-            </a:r>
-            <a:r>
-              <a:rPr sz="1250"/>
-              <a:t>RL Priority Queue (contextual bandit learns from every reviewer decision) · Cascade Impact Prediction (BFS shows downstream project slip) · Active Learning (matching confidence recalibrates with feedback)</a:t>
+              <a:t>Three innovations no existing tool offers:  </a:t>
+            </a:r>
+            <a:r>
+              <a:rPr sz="1200"/>
+              <a:t>① RL Priority Queue — contextual bandit learns optimal review ordering from every decision  ② Cascade Impact Prediction — BFS reveals downstream project slip before approval  ③ Active Learning — matching engine recalibrates from every correction</a:t>
             </a:r>
           </a:p>
         </p:txBody>
@@ -7445,13 +7563,8 @@
           <a:p>
             <a:pPr algn="ctr"/>
             <a:r>
-              <a:rPr b="1" sz="850">
-                <a:solidFill>
-                  <a:srgbClr val="5A5A5A"/>
-                </a:solidFill>
-                <a:latin typeface="Arial"/>
-              </a:rPr>
-              <a:t>DATA</a:t>
+              <a:rPr sz="850" b="1"/>
+              <a:t>INGEST</a:t>
             </a:r>
           </a:p>
         </p:txBody>
@@ -7503,13 +7616,13 @@
             </a:pPr>
             <a:r>
               <a:rPr sz="1050" b="1"/>
-              <a:t>Field Data Sources</a:t>
+              <a:t>Multimodal Input</a:t>
             </a:r>
           </a:p>
           <a:p>
             <a:r>
               <a:rPr sz="850"/>
-              <a:t>DPRs (free text / PDF)</a:t>
+              <a:t>DPRs (free text, PDF)</a:t>
             </a:r>
           </a:p>
           <a:p>
@@ -7521,13 +7634,19 @@
           <a:p>
             <a:r>
               <a:rPr sz="850"/>
-              <a:t>Supervisor voice &amp; text</a:t>
+              <a:t>Supervisor voice (Web Speech API)</a:t>
             </a:r>
           </a:p>
           <a:p>
             <a:r>
               <a:rPr sz="850"/>
-              <a:t>P6 XER · P6 XML · MSP XML</a:t>
+              <a:t>Supervisor typed messages</a:t>
+            </a:r>
+          </a:p>
+          <a:p>
+            <a:r>
+              <a:rPr sz="850"/>
+              <a:t>P6 XER · P6 XML · MSP XML · CSV</a:t>
             </a:r>
           </a:p>
         </p:txBody>
@@ -7556,12 +7675,7 @@
           <a:p>
             <a:pPr algn="ctr"/>
             <a:r>
-              <a:rPr b="1" sz="850">
-                <a:solidFill>
-                  <a:srgbClr val="5A5A5A"/>
-                </a:solidFill>
-                <a:latin typeface="Arial"/>
-              </a:rPr>
+              <a:rPr sz="850" b="1"/>
               <a:t>EXTRACT</a:t>
             </a:r>
           </a:p>
@@ -7614,37 +7728,37 @@
             </a:pPr>
             <a:r>
               <a:rPr sz="1050" b="1"/>
-              <a:t>Hybrid Extraction</a:t>
+              <a:t>Hybrid AI Extraction</a:t>
             </a:r>
           </a:p>
           <a:p>
             <a:r>
               <a:rPr sz="850"/>
-              <a:t>LLM (OpenRouter) + rule fallback</a:t>
+              <a:t>LLM (OpenRouter, free model)</a:t>
             </a:r>
           </a:p>
           <a:p>
             <a:r>
               <a:rPr sz="850"/>
-              <a:t>Confidence scoring per event</a:t>
+              <a:t>Rule-based fallback (always active)</a:t>
             </a:r>
           </a:p>
           <a:p>
             <a:r>
               <a:rPr sz="850"/>
-              <a:t>Deduplication (fingerprint)</a:t>
+              <a:t>Confidence scoring per field</a:t>
             </a:r>
           </a:p>
           <a:p>
             <a:r>
               <a:rPr sz="850"/>
-              <a:t>pandas · pdfplumber · httpx</a:t>
+              <a:t>Cross-event deduplication</a:t>
             </a:r>
           </a:p>
           <a:p>
             <a:r>
               <a:rPr sz="850"/>
-              <a:t>→ ExecutionEvent schema</a:t>
+              <a:t>→ structured ExecutionEvent</a:t>
             </a:r>
           </a:p>
         </p:txBody>
@@ -7726,43 +7840,43 @@
             </a:pPr>
             <a:r>
               <a:rPr sz="1050" b="1"/>
-              <a:t>AI Intelligence Layer</a:t>
+              <a:t>Six AI Capabilities</a:t>
             </a:r>
           </a:p>
           <a:p>
             <a:r>
               <a:rPr sz="850"/>
-              <a:t>7-layer matching engine</a:t>
+              <a:t>① 7-layer semantic matching</a:t>
             </a:r>
           </a:p>
           <a:p>
             <a:r>
               <a:rPr sz="850"/>
-              <a:t>RL Priority Queue (bandit)</a:t>
+              <a:t>② RL Priority Queue (bandit)</a:t>
             </a:r>
           </a:p>
           <a:p>
             <a:r>
               <a:rPr sz="850"/>
-              <a:t>Cascade Impact (BFS)</a:t>
+              <a:t>③ Cascade Impact (BFS graph)</a:t>
             </a:r>
           </a:p>
           <a:p>
             <a:r>
               <a:rPr sz="850"/>
-              <a:t>Conflict &amp; regression detect</a:t>
+              <a:t>④ Conflict + regression detect</a:t>
             </a:r>
           </a:p>
           <a:p>
             <a:r>
               <a:rPr sz="850"/>
-              <a:t>Knowledge Base (hist. risk)</a:t>
+              <a:t>⑤ Knowledge Base (hist. risk)</a:t>
             </a:r>
           </a:p>
           <a:p>
             <a:r>
               <a:rPr sz="850"/>
-              <a:t>Active Learning feedback</a:t>
+              <a:t>⑥ Active Learning (feedback)</a:t>
             </a:r>
           </a:p>
         </p:txBody>
@@ -7791,12 +7905,7 @@
           <a:p>
             <a:pPr algn="ctr"/>
             <a:r>
-              <a:rPr b="1" sz="850">
-                <a:solidFill>
-                  <a:srgbClr val="5A5A5A"/>
-                </a:solidFill>
-                <a:latin typeface="Arial"/>
-              </a:rPr>
+              <a:rPr sz="850" b="1"/>
               <a:t>DECISION</a:t>
             </a:r>
           </a:p>
@@ -7849,7 +7958,7 @@
             </a:pPr>
             <a:r>
               <a:rPr sz="1050" b="1"/>
-              <a:t>Confidence Router</a:t>
+              <a:t>Confidence-Gated Router</a:t>
             </a:r>
           </a:p>
           <a:p>
@@ -7861,7 +7970,7 @@
           <a:p>
             <a:r>
               <a:rPr sz="850"/>
-              <a:t>0.65–0.85 → RL-ranked queue</a:t>
+              <a:t>0.65–0.85 → RL-ranked review</a:t>
             </a:r>
           </a:p>
           <a:p>
@@ -7873,7 +7982,7 @@
           <a:p>
             <a:r>
               <a:rPr sz="850"/>
-              <a:t>Cascade impact per item</a:t>
+              <a:t>Cascade impact per review item</a:t>
             </a:r>
           </a:p>
           <a:p>
@@ -7961,37 +8070,37 @@
             </a:pPr>
             <a:r>
               <a:rPr sz="1050" b="1"/>
-              <a:t>Schedule &amp; Alerts</a:t>
+              <a:t>Schedule Update &amp; Alerts</a:t>
             </a:r>
           </a:p>
           <a:p>
             <a:r>
               <a:rPr sz="850"/>
-              <a:t>P6 dates · Gantt variance</a:t>
+              <a:t>P6 actual dates updated</a:t>
             </a:r>
           </a:p>
           <a:p>
             <a:r>
               <a:rPr sz="850"/>
-              <a:t>Cascade slip alerts</a:t>
+              <a:t>Gantt variance + risk dashboard</a:t>
             </a:r>
           </a:p>
           <a:p>
             <a:r>
               <a:rPr sz="850"/>
-              <a:t>RL weight update on decision</a:t>
+              <a:t>Cascade slip alerts downstream</a:t>
+            </a:r>
+          </a:p>
+          <a:p>
+            <a:r>
+              <a:rPr sz="850"/>
+              <a:t>RL weight sync (persistent)</a:t>
             </a:r>
           </a:p>
           <a:p>
             <a:r>
               <a:rPr sz="850"/>
               <a:t>Full provenance audit trail</a:t>
-            </a:r>
-          </a:p>
-          <a:p>
-            <a:r>
-              <a:rPr sz="850"/>
-              <a:t>Risk dashboard + KB query</a:t>
             </a:r>
           </a:p>
         </p:txBody>
@@ -8064,12 +8173,7 @@
           <a:p>
             <a:pPr algn="ctr"/>
             <a:r>
-              <a:rPr sz="800" i="1">
-                <a:solidFill>
-                  <a:srgbClr val="5A5A5A"/>
-                </a:solidFill>
-                <a:latin typeface="Arial"/>
-              </a:rPr>
+              <a:rPr sz="800"/>
               <a:t>raw data</a:t>
             </a:r>
           </a:p>
@@ -8143,12 +8247,7 @@
           <a:p>
             <a:pPr algn="ctr"/>
             <a:r>
-              <a:rPr sz="800" i="1">
-                <a:solidFill>
-                  <a:srgbClr val="5A5A5A"/>
-                </a:solidFill>
-                <a:latin typeface="Arial"/>
-              </a:rPr>
+              <a:rPr sz="800"/>
               <a:t>events</a:t>
             </a:r>
           </a:p>
@@ -8222,13 +8321,8 @@
           <a:p>
             <a:pPr algn="ctr"/>
             <a:r>
-              <a:rPr sz="800" i="1">
-                <a:solidFill>
-                  <a:srgbClr val="5A5A5A"/>
-                </a:solidFill>
-                <a:latin typeface="Arial"/>
-              </a:rPr>
-              <a:t>match+score</a:t>
+              <a:rPr sz="800"/>
+              <a:t>match + score</a:t>
             </a:r>
           </a:p>
         </p:txBody>
@@ -8301,12 +8395,7 @@
           <a:p>
             <a:pPr algn="ctr"/>
             <a:r>
-              <a:rPr sz="800" i="1">
-                <a:solidFill>
-                  <a:srgbClr val="5A5A5A"/>
-                </a:solidFill>
-                <a:latin typeface="Arial"/>
-              </a:rPr>
+              <a:rPr sz="800"/>
               <a:t>linked</a:t>
             </a:r>
           </a:p>
@@ -8381,7 +8470,7 @@
             <a:pPr algn="ctr"/>
             <a:r>
               <a:rPr sz="950" b="1"/>
-              <a:t>Closed-loop learning — reviewer approve/reject recalibrates matching scores (Active Learning) + reorders the queue by real-world impact (RL Priority) + propagates delay to successor activities (Cascade Impact)</a:t>
+              <a:t>Closed-loop intelligence — Active Learning recalibrates matching scores · RL Priority Queue reorders review by project impact · Cascade Engine propagates delay to successor activities</a:t>
             </a:r>
           </a:p>
         </p:txBody>
@@ -8409,13 +8498,8 @@
           <a:lstStyle/>
           <a:p>
             <a:r>
-              <a:rPr b="1" sz="1300">
-                <a:solidFill>
-                  <a:srgbClr val="1F4E79"/>
-                </a:solidFill>
-                <a:latin typeface="Arial"/>
-              </a:rPr>
-              <a:t>Technology stack — every choice has a reason</a:t>
+              <a:rPr sz="1300" b="1"/>
+              <a:t>Technology stack — 12,800+ lines of Python, 95 source files, 220 automated tests</a:t>
             </a:r>
           </a:p>
         </p:txBody>
@@ -8430,7 +8514,7 @@
         </p:nvGraphicFramePr>
         <p:xfrm>
           <a:off x="365760" y="4224528"/>
-          <a:ext cx="11457432" cy="3025104"/>
+          <a:ext cx="11457432" cy="3985104"/>
         </p:xfrm>
         <a:graphic>
           <a:graphicData uri="http://schemas.openxmlformats.org/drawingml/2006/table">
@@ -8449,14 +8533,8 @@
                     <a:bodyPr wrap="square"/>
                     <a:lstStyle/>
                     <a:p>
-                      <a:pPr algn="l"/>
                       <a:r>
-                        <a:rPr sz="1000" b="1">
-                          <a:solidFill>
-                            <a:srgbClr val="3B3B3B"/>
-                          </a:solidFill>
-                          <a:latin typeface="Arial"/>
-                        </a:rPr>
+                        <a:rPr sz="900" b="1"/>
                         <a:t>Layer</a:t>
                       </a:r>
                     </a:p>
@@ -8472,14 +8550,8 @@
                     <a:bodyPr wrap="square"/>
                     <a:lstStyle/>
                     <a:p>
-                      <a:pPr algn="l"/>
                       <a:r>
-                        <a:rPr sz="1000" b="1">
-                          <a:solidFill>
-                            <a:srgbClr val="3B3B3B"/>
-                          </a:solidFill>
-                          <a:latin typeface="Arial"/>
-                        </a:rPr>
+                        <a:rPr sz="900" b="1"/>
                         <a:t>Technology</a:t>
                       </a:r>
                     </a:p>
@@ -8495,14 +8567,8 @@
                     <a:bodyPr wrap="square"/>
                     <a:lstStyle/>
                     <a:p>
-                      <a:pPr algn="l"/>
                       <a:r>
-                        <a:rPr sz="1000" b="1">
-                          <a:solidFill>
-                            <a:srgbClr val="3B3B3B"/>
-                          </a:solidFill>
-                          <a:latin typeface="Arial"/>
-                        </a:rPr>
+                        <a:rPr sz="900" b="1"/>
                         <a:t>Why this choice</a:t>
                       </a:r>
                     </a:p>
@@ -8520,14 +8586,8 @@
                     <a:bodyPr wrap="square"/>
                     <a:lstStyle/>
                     <a:p>
-                      <a:pPr algn="l"/>
                       <a:r>
-                        <a:rPr sz="950" b="1">
-                          <a:solidFill>
-                            <a:srgbClr val="1F4E79"/>
-                          </a:solidFill>
-                          <a:latin typeface="Arial"/>
-                        </a:rPr>
+                        <a:rPr sz="900" b="1"/>
                         <a:t>Event extraction</a:t>
                       </a:r>
                     </a:p>
@@ -8544,7 +8604,7 @@
                     <a:lstStyle/>
                     <a:p>
                       <a:r>
-                        <a:rPr sz="900"/>
+                        <a:rPr sz="850"/>
                         <a:t>OpenRouter LLM (free) + regex/keyword fallback · pandas · pdfplumber · httpx</a:t>
                       </a:r>
                     </a:p>
@@ -8561,8 +8621,8 @@
                     <a:lstStyle/>
                     <a:p>
                       <a:r>
-                        <a:rPr sz="900"/>
-                        <a:t>Hybrid: rule-based always runs (zero cost); LLM fills gaps on demand. Runs offline.</a:t>
+                        <a:rPr sz="850"/>
+                        <a:t>Hybrid: rule-based always runs (zero cost, offline); LLM fills gaps on demand via API</a:t>
                       </a:r>
                     </a:p>
                   </a:txBody>
@@ -8597,8 +8657,8 @@
                     <a:lstStyle/>
                     <a:p>
                       <a:r>
-                        <a:rPr sz="900"/>
-                        <a:t>Sentence-Transformers (MiniLM-L6-v2) · TF-IDF fallback · cosine similarity</a:t>
+                        <a:rPr sz="850"/>
+                        <a:t>Sentence-Transformers (MiniLM-L6-v2, 384-dim) · TF-IDF fallback · cosine similarity</a:t>
                       </a:r>
                     </a:p>
                   </a:txBody>
@@ -8614,221 +8674,8 @@
                     <a:lstStyle/>
                     <a:p>
                       <a:r>
-                        <a:rPr sz="900"/>
-                        <a:t>Semantic &gt; keyword for EPC jargon; runs on CPU; 7 signals stacked for robustness</a:t>
-                      </a:r>
-                    </a:p>
-                  </a:txBody>
-                  <a:tcPr marL="54864" marR="54864" marT="13716" marB="13716" anchor="ctr">
-                    <a:solidFill>
-                      <a:srgbClr val="FFFFFF"/>
-                    </a:solidFill>
-                  </a:tcPr>
-                </a:tc>
-              </a:tr>
-              <a:tr h="283464">
-                <a:tc>
-                  <a:txBody>
-                    <a:bodyPr wrap="square"/>
-                    <a:lstStyle/>
-                    <a:p>
-                      <a:pPr algn="l"/>
-                      <a:r>
-                        <a:rPr sz="950" b="1">
-                          <a:solidFill>
-                            <a:srgbClr val="1F4E79"/>
-                          </a:solidFill>
-                          <a:latin typeface="Arial"/>
-                        </a:rPr>
-                        <a:t>Backend / API</a:t>
-                      </a:r>
-                    </a:p>
-                  </a:txBody>
-                  <a:tcPr marL="54864" marR="54864" marT="13716" marB="13716" anchor="ctr">
-                    <a:solidFill>
-                      <a:srgbClr val="FFFFFF"/>
-                    </a:solidFill>
-                  </a:tcPr>
-                </a:tc>
-                <a:tc>
-                  <a:txBody>
-                    <a:bodyPr wrap="square"/>
-                    <a:lstStyle/>
-                    <a:p>
-                      <a:pPr algn="l"/>
-                      <a:r>
-                        <a:rPr sz="950" b="0">
-                          <a:solidFill>
-                            <a:srgbClr val="262626"/>
-                          </a:solidFill>
-                          <a:latin typeface="Arial"/>
-                        </a:rPr>
-                        <a:t>Python · FastAPI · Pydantic</a:t>
-                      </a:r>
-                    </a:p>
-                  </a:txBody>
-                  <a:tcPr marL="54864" marR="54864" marT="13716" marB="13716" anchor="ctr">
-                    <a:solidFill>
-                      <a:srgbClr val="FFFFFF"/>
-                    </a:solidFill>
-                  </a:tcPr>
-                </a:tc>
-                <a:tc>
-                  <a:txBody>
-                    <a:bodyPr wrap="square"/>
-                    <a:lstStyle/>
-                    <a:p>
-                      <a:pPr algn="l"/>
-                      <a:r>
-                        <a:rPr sz="950" b="0">
-                          <a:solidFill>
-                            <a:srgbClr val="262626"/>
-                          </a:solidFill>
-                          <a:latin typeface="Arial"/>
-                        </a:rPr>
-                        <a:t>Lightweight, typed REST layer over Python ML inference</a:t>
-                      </a:r>
-                    </a:p>
-                  </a:txBody>
-                  <a:tcPr marL="54864" marR="54864" marT="13716" marB="13716" anchor="ctr">
-                    <a:solidFill>
-                      <a:srgbClr val="FFFFFF"/>
-                    </a:solidFill>
-                  </a:tcPr>
-                </a:tc>
-              </a:tr>
-              <a:tr h="283464">
-                <a:tc>
-                  <a:txBody>
-                    <a:bodyPr wrap="square"/>
-                    <a:lstStyle/>
-                    <a:p>
-                      <a:pPr algn="l"/>
-                      <a:r>
-                        <a:rPr sz="950" b="1">
-                          <a:solidFill>
-                            <a:srgbClr val="1F4E79"/>
-                          </a:solidFill>
-                          <a:latin typeface="Arial"/>
-                        </a:rPr>
-                        <a:t>Storage</a:t>
-                      </a:r>
-                    </a:p>
-                  </a:txBody>
-                  <a:tcPr marL="54864" marR="54864" marT="13716" marB="13716" anchor="ctr">
-                    <a:solidFill>
-                      <a:srgbClr val="FFFFFF"/>
-                    </a:solidFill>
-                  </a:tcPr>
-                </a:tc>
-                <a:tc>
-                  <a:txBody>
-                    <a:bodyPr wrap="square"/>
-                    <a:lstStyle/>
-                    <a:p>
-                      <a:pPr algn="l"/>
-                      <a:r>
-                        <a:rPr sz="950" b="0">
-                          <a:solidFill>
-                            <a:srgbClr val="262626"/>
-                          </a:solidFill>
-                          <a:latin typeface="Arial"/>
-                        </a:rPr>
-                        <a:t>In-memory + CSV/JSON (demo) · PostgreSQL + pgvector (production)</a:t>
-                      </a:r>
-                    </a:p>
-                  </a:txBody>
-                  <a:tcPr marL="54864" marR="54864" marT="13716" marB="13716" anchor="ctr">
-                    <a:solidFill>
-                      <a:srgbClr val="FFFFFF"/>
-                    </a:solidFill>
-                  </a:tcPr>
-                </a:tc>
-                <a:tc>
-                  <a:txBody>
-                    <a:bodyPr wrap="square"/>
-                    <a:lstStyle/>
-                    <a:p>
-                      <a:pPr algn="l"/>
-                      <a:r>
-                        <a:rPr sz="950" b="0">
-                          <a:solidFill>
-                            <a:srgbClr val="262626"/>
-                          </a:solidFill>
-                          <a:latin typeface="Arial"/>
-                        </a:rPr>
-                        <a:t>Zero-setup demo; pgvector scales to full-project search</a:t>
-                      </a:r>
-                    </a:p>
-                  </a:txBody>
-                  <a:tcPr marL="54864" marR="54864" marT="13716" marB="13716" anchor="ctr">
-                    <a:solidFill>
-                      <a:srgbClr val="FFFFFF"/>
-                    </a:solidFill>
-                  </a:tcPr>
-                </a:tc>
-              </a:tr>
-              <a:tr h="283464">
-                <a:tc>
-                  <a:txBody>
-                    <a:bodyPr wrap="square"/>
-                    <a:lstStyle/>
-                    <a:p>
-                      <a:pPr algn="l"/>
-                      <a:r>
-                        <a:rPr sz="950" b="1">
-                          <a:solidFill>
-                            <a:srgbClr val="1F4E79"/>
-                          </a:solidFill>
-                          <a:latin typeface="Arial"/>
-                        </a:rPr>
-                        <a:t>Frontend</a:t>
-                      </a:r>
-                    </a:p>
-                  </a:txBody>
-                  <a:tcPr marL="54864" marR="54864" marT="13716" marB="13716" anchor="ctr">
-                    <a:solidFill>
-                      <a:srgbClr val="FFFFFF"/>
-                    </a:solidFill>
-                  </a:tcPr>
-                </a:tc>
-                <a:tc>
-                  <a:txBody>
-                    <a:bodyPr wrap="square"/>
-                    <a:lstStyle/>
-                    <a:p>
-                      <a:pPr algn="l"/>
-                      <a:r>
-                        <a:rPr sz="950" b="0">
-                          <a:solidFill>
-                            <a:srgbClr val="262626"/>
-                          </a:solidFill>
-                          <a:latin typeface="Arial"/>
-                        </a:rPr>
-                        <a:t>Vanilla JS (HTML/CSS), served by FastAPI</a:t>
-                      </a:r>
-                    </a:p>
-                  </a:txBody>
-                  <a:tcPr marL="54864" marR="54864" marT="13716" marB="13716" anchor="ctr">
-                    <a:solidFill>
-                      <a:srgbClr val="FFFFFF"/>
-                    </a:solidFill>
-                  </a:tcPr>
-                </a:tc>
-                <a:tc>
-                  <a:txBody>
-                    <a:bodyPr wrap="square"/>
-                    <a:lstStyle/>
-                    <a:p>
-                      <a:pPr algn="l"/>
-                      <a:r>
-                        <a:rPr sz="950" b="0">
-                          <a:solidFill>
-                            <a:srgbClr val="262626"/>
-                          </a:solidFill>
-                          <a:latin typeface="Arial"/>
-                        </a:rPr>
-                        <a:t>No framework; review queue, Gantt &amp; risk dashboard</a:t>
+                        <a:rPr sz="850"/>
+                        <a:t>Semantic &gt; keyword for EPC jargon; runs on CPU (no GPU); TF-IDF graceful degradation</a:t>
                       </a:r>
                     </a:p>
                   </a:txBody>
@@ -8847,7 +8694,7 @@
                     <a:p>
                       <a:r>
                         <a:rPr sz="900" b="1"/>
-                        <a:t>Active learning + RL</a:t>
+                        <a:t>Backend / API</a:t>
                       </a:r>
                     </a:p>
                   </a:txBody>
@@ -8863,8 +8710,8 @@
                     <a:lstStyle/>
                     <a:p>
                       <a:r>
-                        <a:rPr sz="900"/>
-                        <a:t>Feedback store (JSON) · contextual bandit · online gradient descent</a:t>
+                        <a:rPr sz="850"/>
+                        <a:t>Python 3.12 · FastAPI · Pydantic v2 · JWT HS256 (role-based auth)</a:t>
                       </a:r>
                     </a:p>
                   </a:txBody>
@@ -8880,8 +8727,167 @@
                     <a:lstStyle/>
                     <a:p>
                       <a:r>
-                        <a:rPr sz="900"/>
-                        <a:t>Matching recalibrates from corrections; RL reorders queue by project impact</a:t>
+                        <a:rPr sz="850"/>
+                        <a:t>Typed REST layer; supervisor/admin roles; 30 API endpoints; &lt;100ms response</a:t>
+                      </a:r>
+                    </a:p>
+                  </a:txBody>
+                  <a:tcPr marL="54864" marR="54864" marT="13716" marB="13716" anchor="ctr">
+                    <a:solidFill>
+                      <a:srgbClr val="FFFFFF"/>
+                    </a:solidFill>
+                  </a:tcPr>
+                </a:tc>
+              </a:tr>
+              <a:tr h="283464">
+                <a:tc>
+                  <a:txBody>
+                    <a:bodyPr wrap="square"/>
+                    <a:lstStyle/>
+                    <a:p>
+                      <a:r>
+                        <a:rPr sz="900" b="1"/>
+                        <a:t>Schedule parsing</a:t>
+                      </a:r>
+                    </a:p>
+                  </a:txBody>
+                  <a:tcPr marL="54864" marR="54864" marT="13716" marB="13716" anchor="ctr">
+                    <a:solidFill>
+                      <a:srgbClr val="FFFFFF"/>
+                    </a:solidFill>
+                  </a:tcPr>
+                </a:tc>
+                <a:tc>
+                  <a:txBody>
+                    <a:bodyPr wrap="square"/>
+                    <a:lstStyle/>
+                    <a:p>
+                      <a:r>
+                        <a:rPr sz="850"/>
+                        <a:t>P6 XER · P6 XML · MSP XML · CSV — auto-detected by header, not extension</a:t>
+                      </a:r>
+                    </a:p>
+                  </a:txBody>
+                  <a:tcPr marL="54864" marR="54864" marT="13716" marB="13716" anchor="ctr">
+                    <a:solidFill>
+                      <a:srgbClr val="FFFFFF"/>
+                    </a:solidFill>
+                  </a:tcPr>
+                </a:tc>
+                <a:tc>
+                  <a:txBody>
+                    <a:bodyPr wrap="square"/>
+                    <a:lstStyle/>
+                    <a:p>
+                      <a:r>
+                        <a:rPr sz="850"/>
+                        <a:t>5 parser classes; WBS hierarchy, predecessors/successors, planned dates preserved</a:t>
+                      </a:r>
+                    </a:p>
+                  </a:txBody>
+                  <a:tcPr marL="54864" marR="54864" marT="13716" marB="13716" anchor="ctr">
+                    <a:solidFill>
+                      <a:srgbClr val="FFFFFF"/>
+                    </a:solidFill>
+                  </a:tcPr>
+                </a:tc>
+              </a:tr>
+              <a:tr h="283464">
+                <a:tc>
+                  <a:txBody>
+                    <a:bodyPr wrap="square"/>
+                    <a:lstStyle/>
+                    <a:p>
+                      <a:r>
+                        <a:rPr sz="900" b="1"/>
+                        <a:t>Frontend</a:t>
+                      </a:r>
+                    </a:p>
+                  </a:txBody>
+                  <a:tcPr marL="54864" marR="54864" marT="13716" marB="13716" anchor="ctr">
+                    <a:solidFill>
+                      <a:srgbClr val="FFFFFF"/>
+                    </a:solidFill>
+                  </a:tcPr>
+                </a:tc>
+                <a:tc>
+                  <a:txBody>
+                    <a:bodyPr wrap="square"/>
+                    <a:lstStyle/>
+                    <a:p>
+                      <a:r>
+                        <a:rPr sz="850"/>
+                        <a:t>Vanilla JS/HTML/CSS · Web Speech API · zero build tools</a:t>
+                      </a:r>
+                    </a:p>
+                  </a:txBody>
+                  <a:tcPr marL="54864" marR="54864" marT="13716" marB="13716" anchor="ctr">
+                    <a:solidFill>
+                      <a:srgbClr val="FFFFFF"/>
+                    </a:solidFill>
+                  </a:tcPr>
+                </a:tc>
+                <a:tc>
+                  <a:txBody>
+                    <a:bodyPr wrap="square"/>
+                    <a:lstStyle/>
+                    <a:p>
+                      <a:r>
+                        <a:rPr sz="850"/>
+                        <a:t>10 views (Gantt, risk, review queue, audit trail); works offline; large touch targets</a:t>
+                      </a:r>
+                    </a:p>
+                  </a:txBody>
+                  <a:tcPr marL="54864" marR="54864" marT="13716" marB="13716" anchor="ctr">
+                    <a:solidFill>
+                      <a:srgbClr val="FFFFFF"/>
+                    </a:solidFill>
+                  </a:tcPr>
+                </a:tc>
+              </a:tr>
+              <a:tr h="283464">
+                <a:tc>
+                  <a:txBody>
+                    <a:bodyPr wrap="square"/>
+                    <a:lstStyle/>
+                    <a:p>
+                      <a:r>
+                        <a:rPr sz="900" b="1"/>
+                        <a:t>RL + Active Learning</a:t>
+                      </a:r>
+                    </a:p>
+                  </a:txBody>
+                  <a:tcPr marL="54864" marR="54864" marT="13716" marB="13716" anchor="ctr">
+                    <a:solidFill>
+                      <a:srgbClr val="FFFFFF"/>
+                    </a:solidFill>
+                  </a:tcPr>
+                </a:tc>
+                <a:tc>
+                  <a:txBody>
+                    <a:bodyPr wrap="square"/>
+                    <a:lstStyle/>
+                    <a:p>
+                      <a:r>
+                        <a:rPr sz="850"/>
+                        <a:t>Contextual bandit · online gradient descent (lr=0.05) · feedback store (JSON)</a:t>
+                      </a:r>
+                    </a:p>
+                  </a:txBody>
+                  <a:tcPr marL="54864" marR="54864" marT="13716" marB="13716" anchor="ctr">
+                    <a:solidFill>
+                      <a:srgbClr val="FFFFFF"/>
+                    </a:solidFill>
+                  </a:tcPr>
+                </a:tc>
+                <a:tc>
+                  <a:txBody>
+                    <a:bodyPr wrap="square"/>
+                    <a:lstStyle/>
+                    <a:p>
+                      <a:r>
+                        <a:rPr sz="850"/>
+                        <a:t>5-feature vector; weights persist to disk; queue reorders after every decision</a:t>
                       </a:r>
                     </a:p>
                   </a:txBody>
@@ -9051,6 +9057,165 @@
                   </a:tcPr>
                 </a:tc>
               </a:tr>
+              <a:tr h="320000">
+                <a:tc>
+                  <a:txBody>
+                    <a:bodyPr wrap="square"/>
+                    <a:lstStyle/>
+                    <a:p>
+                      <a:r>
+                        <a:rPr sz="850" b="1"/>
+                        <a:t>Cascade impact</a:t>
+                      </a:r>
+                    </a:p>
+                  </a:txBody>
+                  <a:tcPr marL="54864" marR="54864" marT="13716" marB="13716" anchor="ctr">
+                    <a:solidFill>
+                      <a:srgbClr val="FFFFFF"/>
+                    </a:solidFill>
+                  </a:tcPr>
+                </a:tc>
+                <a:tc>
+                  <a:txBody>
+                    <a:bodyPr wrap="square"/>
+                    <a:lstStyle/>
+                    <a:p>
+                      <a:r>
+                        <a:rPr sz="850"/>
+                        <a:t>BFS successor traversal · predecessor/successor graph from P6 schedule data</a:t>
+                      </a:r>
+                    </a:p>
+                  </a:txBody>
+                  <a:tcPr marL="54864" marR="54864" marT="13716" marB="13716" anchor="ctr">
+                    <a:solidFill>
+                      <a:srgbClr val="FFFFFF"/>
+                    </a:solidFill>
+                  </a:tcPr>
+                </a:tc>
+                <a:tc>
+                  <a:txBody>
+                    <a:bodyPr wrap="square"/>
+                    <a:lstStyle/>
+                    <a:p>
+                      <a:r>
+                        <a:rPr sz="850"/>
+                        <a:t>Unique: shows downstream slip (days, activities, disciplines) before reviewer decides</a:t>
+                      </a:r>
+                    </a:p>
+                  </a:txBody>
+                  <a:tcPr marL="54864" marR="54864" marT="13716" marB="13716" anchor="ctr">
+                    <a:solidFill>
+                      <a:srgbClr val="FFFFFF"/>
+                    </a:solidFill>
+                  </a:tcPr>
+                </a:tc>
+              </a:tr>
+              <a:tr h="320000">
+                <a:tc>
+                  <a:txBody>
+                    <a:bodyPr wrap="square"/>
+                    <a:lstStyle/>
+                    <a:p>
+                      <a:r>
+                        <a:rPr sz="850" b="1"/>
+                        <a:t>Knowledge base</a:t>
+                      </a:r>
+                    </a:p>
+                  </a:txBody>
+                  <a:tcPr marL="54864" marR="54864" marT="13716" marB="13716" anchor="ctr">
+                    <a:solidFill>
+                      <a:srgbClr val="FFFFFF"/>
+                    </a:solidFill>
+                  </a:tcPr>
+                </a:tc>
+                <a:tc>
+                  <a:txBody>
+                    <a:bodyPr wrap="square"/>
+                    <a:lstStyle/>
+                    <a:p>
+                      <a:r>
+                        <a:rPr sz="850"/>
+                        <a:t>Vector similarity search · 49 historical records · NL query engine · productivity tracker</a:t>
+                      </a:r>
+                    </a:p>
+                  </a:txBody>
+                  <a:tcPr marL="54864" marR="54864" marT="13716" marB="13716" anchor="ctr">
+                    <a:solidFill>
+                      <a:srgbClr val="FFFFFF"/>
+                    </a:solidFill>
+                  </a:tcPr>
+                </a:tc>
+                <a:tc>
+                  <a:txBody>
+                    <a:bodyPr wrap="square"/>
+                    <a:lstStyle/>
+                    <a:p>
+                      <a:r>
+                        <a:rPr sz="850"/>
+                        <a:t>Institutional memory: delay rates, causes, duration patterns persist across projects</a:t>
+                      </a:r>
+                    </a:p>
+                  </a:txBody>
+                  <a:tcPr marL="54864" marR="54864" marT="13716" marB="13716" anchor="ctr">
+                    <a:solidFill>
+                      <a:srgbClr val="FFFFFF"/>
+                    </a:solidFill>
+                  </a:tcPr>
+                </a:tc>
+              </a:tr>
+              <a:tr h="320000">
+                <a:tc>
+                  <a:txBody>
+                    <a:bodyPr wrap="square"/>
+                    <a:lstStyle/>
+                    <a:p>
+                      <a:r>
+                        <a:rPr sz="850" b="1"/>
+                        <a:t>Conflict engine</a:t>
+                      </a:r>
+                    </a:p>
+                  </a:txBody>
+                  <a:tcPr marL="54864" marR="54864" marT="13716" marB="13716" anchor="ctr">
+                    <a:solidFill>
+                      <a:srgbClr val="FFFFFF"/>
+                    </a:solidFill>
+                  </a:tcPr>
+                </a:tc>
+                <a:tc>
+                  <a:txBody>
+                    <a:bodyPr wrap="square"/>
+                    <a:lstStyle/>
+                    <a:p>
+                      <a:r>
+                        <a:rPr sz="850"/>
+                        <a:t>Cross-source detection · state regression (e.g. completed→in_progress) flagging</a:t>
+                      </a:r>
+                    </a:p>
+                  </a:txBody>
+                  <a:tcPr marL="54864" marR="54864" marT="13716" marB="13716" anchor="ctr">
+                    <a:solidFill>
+                      <a:srgbClr val="FFFFFF"/>
+                    </a:solidFill>
+                  </a:tcPr>
+                </a:tc>
+                <a:tc>
+                  <a:txBody>
+                    <a:bodyPr wrap="square"/>
+                    <a:lstStyle/>
+                    <a:p>
+                      <a:r>
+                        <a:rPr sz="850"/>
+                        <a:t>Catches contradictory reports; forces explicit trust resolution with audit trail</a:t>
+                      </a:r>
+                    </a:p>
+                  </a:txBody>
+                  <a:tcPr marL="54864" marR="54864" marT="13716" marB="13716" anchor="ctr">
+                    <a:solidFill>
+                      <a:srgbClr val="FFFFFF"/>
+                    </a:solidFill>
+                  </a:tcPr>
+                </a:tc>
+              </a:tr>
             </a:tbl>
           </a:graphicData>
         </a:graphic>
@@ -9465,49 +9630,12 @@
           <a:p>
             <a:pPr algn="ctr"/>
             <a:r>
-              <a:rPr sz="1200" b="1">
-                <a:solidFill>
-                  <a:srgbClr val="1F4E79"/>
-                </a:solidFill>
-                <a:latin typeface="Arial"/>
-              </a:rPr>
+              <a:rPr sz="1200" b="1"/>
               <a:t>Evidence, not adjectives:  </a:t>
             </a:r>
             <a:r>
-              <a:rPr sz="1200" b="0">
-                <a:solidFill>
-                  <a:srgbClr val="262626"/>
-                </a:solidFill>
-                <a:latin typeface="Arial"/>
-              </a:rPr>
-              <a:t>the MiniLM matcher (~80 MB) runs on CPU; the demo reconciles a </a:t>
-            </a:r>
-            <a:r>
-              <a:rPr sz="1200" b="1">
-                <a:solidFill>
-                  <a:srgbClr val="262626"/>
-                </a:solidFill>
-                <a:latin typeface="Arial"/>
-              </a:rPr>
-              <a:t>42-activity Primavera P6 schedule</a:t>
-            </a:r>
-            <a:r>
-              <a:rPr sz="1200" b="0">
-                <a:solidFill>
-                  <a:srgbClr val="262626"/>
-                </a:solidFill>
-                <a:latin typeface="Arial"/>
-              </a:rPr>
-              <a:t> against </a:t>
-            </a:r>
-            <a:r>
-              <a:rPr sz="1200" b="1">
-                <a:solidFill>
-                  <a:srgbClr val="262626"/>
-                </a:solidFill>
-                <a:latin typeface="Arial"/>
-              </a:rPr>
-              <a:t>3 days of daily reports.</a:t>
+              <a:rPr sz="1200"/>
+              <a:t>Working prototype — 12,800 lines of Python · 220 passing tests · 30 API endpoints · 41-activity P6 schedule · 49 historical records · 3 daily progress reports · 5 discipline parsers · runs with uvicorn server:app and a browser.</a:t>
             </a:r>
           </a:p>
         </p:txBody>
@@ -9558,118 +9686,44 @@
               </a:spcAft>
             </a:pPr>
             <a:r>
-              <a:rPr b="1" sz="1300">
-                <a:solidFill>
-                  <a:srgbClr val="1F4E79"/>
-                </a:solidFill>
-                <a:latin typeface="Arial"/>
-              </a:rPr>
+              <a:rPr sz="1300" b="1"/>
               <a:t>Feasibility — can we build it?</a:t>
             </a:r>
           </a:p>
           <a:p>
-            <a:pPr marL="182880" indent="-182880">
-              <a:lnSpc>
-                <a:spcPct val="102000"/>
-              </a:lnSpc>
-              <a:spcAft>
-                <a:spcPts val="300"/>
-              </a:spcAft>
-              <a:buFont typeface="Arial"/>
-              <a:buChar char="•"/>
-            </a:pPr>
-            <a:r>
-              <a:rPr sz="1000">
-                <a:solidFill>
-                  <a:srgbClr val="262626"/>
-                </a:solidFill>
-                <a:latin typeface="Arial"/>
-              </a:rPr>
-              <a:t>Matching runs on a standard laptop CPU — no GPU</a:t>
-            </a:r>
-          </a:p>
-          <a:p>
-            <a:pPr marL="182880" indent="-182880">
-              <a:lnSpc>
-                <a:spcPct val="102000"/>
-              </a:lnSpc>
-              <a:spcAft>
-                <a:spcPts val="300"/>
-              </a:spcAft>
-              <a:buFont typeface="Arial"/>
-              <a:buChar char="•"/>
-            </a:pPr>
-            <a:r>
-              <a:rPr sz="1000">
-                <a:solidFill>
-                  <a:srgbClr val="262626"/>
-                </a:solidFill>
-                <a:latin typeface="Arial"/>
-              </a:rPr>
-              <a:t>Open-source stack — no proprietary scheduling-tool licences</a:t>
-            </a:r>
-          </a:p>
-          <a:p>
-            <a:pPr marL="182880" indent="-182880">
-              <a:lnSpc>
-                <a:spcPct val="102000"/>
-              </a:lnSpc>
-              <a:spcAft>
-                <a:spcPts val="300"/>
-              </a:spcAft>
-              <a:buFont typeface="Arial"/>
-              <a:buChar char="•"/>
-            </a:pPr>
-            <a:r>
-              <a:rPr sz="1000">
-                <a:solidFill>
-                  <a:srgbClr val="262626"/>
-                </a:solidFill>
-                <a:latin typeface="Arial"/>
-              </a:rPr>
-              <a:t>Primavera P6 XER is a standard export — no proprietary API</a:t>
-            </a:r>
-          </a:p>
-          <a:p>
-            <a:pPr marL="182880" indent="-182880">
-              <a:lnSpc>
-                <a:spcPct val="102000"/>
-              </a:lnSpc>
-              <a:spcAft>
-                <a:spcPts val="300"/>
-              </a:spcAft>
-              <a:buFont typeface="Arial"/>
-              <a:buChar char="•"/>
-            </a:pPr>
-            <a:r>
-              <a:rPr sz="1000">
-                <a:solidFill>
-                  <a:srgbClr val="262626"/>
-                </a:solidFill>
-                <a:latin typeface="Arial"/>
-              </a:rPr>
-              <a:t>Core MVP fits the 3-day internal-hackathon window</a:t>
-            </a:r>
-          </a:p>
-          <a:p>
-            <a:pPr marL="182880" indent="-182880">
-              <a:lnSpc>
-                <a:spcPct val="102000"/>
-              </a:lnSpc>
-              <a:spcAft>
-                <a:spcPts val="300"/>
-              </a:spcAft>
-              <a:buFont typeface="Arial"/>
-              <a:buChar char="•"/>
-            </a:pPr>
-            <a:r>
-              <a:rPr sz="1000">
-                <a:solidFill>
-                  <a:srgbClr val="262626"/>
-                </a:solidFill>
-                <a:latin typeface="Arial"/>
-              </a:rPr>
-              <a:t>Synthetic Oil India dataset already prepared for the demo</a:t>
+            <a:r>
+              <a:rPr sz="1000"/>
+              <a:t>MiniLM matcher (~80 MB) runs on any laptop CPU — no GPU required</a:t>
+            </a:r>
+          </a:p>
+          <a:p>
+            <a:r>
+              <a:rPr sz="1000"/>
+              <a:t>100% open-source stack — zero proprietary scheduling-tool licences</a:t>
+            </a:r>
+          </a:p>
+          <a:p>
+            <a:r>
+              <a:rPr sz="1000"/>
+              <a:t>P6 XER/XML are standard exports — no proprietary API integration</a:t>
+            </a:r>
+          </a:p>
+          <a:p>
+            <a:r>
+              <a:rPr sz="1000"/>
+              <a:t>LLM extraction uses a free model (Gemini 2.0 Flash) — zero API cost</a:t>
+            </a:r>
+          </a:p>
+          <a:p>
+            <a:r>
+              <a:rPr sz="1000"/>
+              <a:t>Works fully offline: rule-based extraction + TF-IDF matching fallback</a:t>
+            </a:r>
+          </a:p>
+          <a:p>
+            <a:r>
+              <a:rPr sz="1000"/>
+              <a:t>Synthetic Oil India dataset (42 activities, 3 DPRs, 25 labelled pairs) ready</a:t>
             </a:r>
           </a:p>
         </p:txBody>
@@ -9720,97 +9774,44 @@
               </a:spcAft>
             </a:pPr>
             <a:r>
-              <a:rPr b="1" sz="1300">
-                <a:solidFill>
-                  <a:srgbClr val="2E5D1F"/>
-                </a:solidFill>
-                <a:latin typeface="Arial"/>
-              </a:rPr>
+              <a:rPr sz="1300" b="1"/>
               <a:t>Viability — will it work in practice?</a:t>
             </a:r>
           </a:p>
           <a:p>
-            <a:pPr marL="182880" indent="-182880">
-              <a:lnSpc>
-                <a:spcPct val="102000"/>
-              </a:lnSpc>
-              <a:spcAft>
-                <a:spcPts val="300"/>
-              </a:spcAft>
-              <a:buFont typeface="Arial"/>
-              <a:buChar char="•"/>
-            </a:pPr>
-            <a:r>
-              <a:rPr sz="1000">
-                <a:solidFill>
-                  <a:srgbClr val="262626"/>
-                </a:solidFill>
-                <a:latin typeface="Arial"/>
-              </a:rPr>
-              <a:t>Zero workflow change — planners submit the DPRs they already write</a:t>
-            </a:r>
-          </a:p>
-          <a:p>
-            <a:pPr marL="182880" indent="-182880">
-              <a:lnSpc>
-                <a:spcPct val="102000"/>
-              </a:lnSpc>
-              <a:spcAft>
-                <a:spcPts val="300"/>
-              </a:spcAft>
-              <a:buFont typeface="Arial"/>
-              <a:buChar char="•"/>
-            </a:pPr>
-            <a:r>
-              <a:rPr sz="1000">
-                <a:solidFill>
-                  <a:srgbClr val="262626"/>
-                </a:solidFill>
-                <a:latin typeface="Arial"/>
-              </a:rPr>
-              <a:t>Runs on servers Oil India already operates (on-prem capable)</a:t>
-            </a:r>
-          </a:p>
-          <a:p>
-            <a:pPr marL="182880" indent="-182880">
-              <a:lnSpc>
-                <a:spcPct val="102000"/>
-              </a:lnSpc>
-              <a:spcAft>
-                <a:spcPts val="300"/>
-              </a:spcAft>
-              <a:buFont typeface="Arial"/>
-              <a:buChar char="•"/>
-            </a:pPr>
-            <a:r>
-              <a:rPr sz="1000">
-                <a:solidFill>
-                  <a:srgbClr val="262626"/>
-                </a:solidFill>
-                <a:latin typeface="Arial"/>
-              </a:rPr>
-              <a:t>Same engine scales from a 42-activity pilot to 5000+ activities</a:t>
-            </a:r>
-          </a:p>
-          <a:p>
-            <a:pPr marL="182880" indent="-182880">
-              <a:lnSpc>
-                <a:spcPct val="102000"/>
-              </a:lnSpc>
-              <a:spcAft>
-                <a:spcPts val="300"/>
-              </a:spcAft>
-              <a:buFont typeface="Arial"/>
-              <a:buChar char="•"/>
-            </a:pPr>
-            <a:r>
-              <a:rPr sz="1000">
-                <a:solidFill>
-                  <a:srgbClr val="262626"/>
-                </a:solidFill>
-                <a:latin typeface="Arial"/>
-              </a:rPr>
-              <a:t>Human-in-the-loop: planner reviews only medium-confidence matches</a:t>
+            <a:r>
+              <a:rPr sz="1000"/>
+              <a:t>Zero workflow change — planners submit the same DPRs they already write</a:t>
+            </a:r>
+          </a:p>
+          <a:p>
+            <a:r>
+              <a:rPr sz="1000"/>
+              <a:t>Voice input via browser — supervisor speaks, SYNAPSE understands</a:t>
+            </a:r>
+          </a:p>
+          <a:p>
+            <a:r>
+              <a:rPr sz="1000"/>
+              <a:t>Runs on servers Oil India already operates (on-prem, no cloud dependency)</a:t>
+            </a:r>
+          </a:p>
+          <a:p>
+            <a:r>
+              <a:rPr sz="1000"/>
+              <a:t>Scales from 42-activity pilot to 5,000+ activities (same architecture)</a:t>
+            </a:r>
+          </a:p>
+          <a:p>
+            <a:r>
+              <a:rPr sz="1000"/>
+              <a:t>Human-in-the-loop: only medium-confidence matches need review</a:t>
+            </a:r>
+          </a:p>
+          <a:p>
+            <a:r>
+              <a:rPr sz="1000"/>
+              <a:t>RL queue shrinks review burden as the system learns patterns</a:t>
             </a:r>
           </a:p>
         </p:txBody>
@@ -9838,13 +9839,8 @@
           <a:lstStyle/>
           <a:p>
             <a:r>
-              <a:rPr b="1" sz="1300">
-                <a:solidFill>
-                  <a:srgbClr val="1F4E79"/>
-                </a:solidFill>
-                <a:latin typeface="Arial"/>
-              </a:rPr>
-              <a:t>Risks &amp; mitigations — we don’t hide them (honest teams score higher)</a:t>
+              <a:rPr sz="1300" b="1"/>
+              <a:t>Risks &amp; mitigations — we don't hide them</a:t>
             </a:r>
           </a:p>
         </p:txBody>
@@ -9879,14 +9875,8 @@
                     <a:bodyPr wrap="square"/>
                     <a:lstStyle/>
                     <a:p>
-                      <a:pPr algn="l"/>
                       <a:r>
-                        <a:rPr sz="1000" b="1">
-                          <a:solidFill>
-                            <a:srgbClr val="3B3B3B"/>
-                          </a:solidFill>
-                          <a:latin typeface="Arial"/>
-                        </a:rPr>
+                        <a:rPr sz="950" b="1"/>
                         <a:t>Risk</a:t>
                       </a:r>
                     </a:p>
@@ -9902,14 +9892,8 @@
                     <a:bodyPr wrap="square"/>
                     <a:lstStyle/>
                     <a:p>
-                      <a:pPr algn="ctr"/>
                       <a:r>
-                        <a:rPr sz="1000" b="1">
-                          <a:solidFill>
-                            <a:srgbClr val="3B3B3B"/>
-                          </a:solidFill>
-                          <a:latin typeface="Arial"/>
-                        </a:rPr>
+                        <a:rPr sz="950" b="1"/>
                         <a:t>Prob.</a:t>
                       </a:r>
                     </a:p>
@@ -9925,14 +9909,8 @@
                     <a:bodyPr wrap="square"/>
                     <a:lstStyle/>
                     <a:p>
-                      <a:pPr algn="ctr"/>
                       <a:r>
-                        <a:rPr sz="1000" b="1">
-                          <a:solidFill>
-                            <a:srgbClr val="3B3B3B"/>
-                          </a:solidFill>
-                          <a:latin typeface="Arial"/>
-                        </a:rPr>
+                        <a:rPr sz="950" b="1"/>
                         <a:t>Impact</a:t>
                       </a:r>
                     </a:p>
@@ -9948,14 +9926,8 @@
                     <a:bodyPr wrap="square"/>
                     <a:lstStyle/>
                     <a:p>
-                      <a:pPr algn="l"/>
                       <a:r>
-                        <a:rPr sz="1000" b="1">
-                          <a:solidFill>
-                            <a:srgbClr val="3B3B3B"/>
-                          </a:solidFill>
-                          <a:latin typeface="Arial"/>
-                        </a:rPr>
+                        <a:rPr sz="950" b="1"/>
                         <a:t>Mitigation</a:t>
                       </a:r>
                     </a:p>
@@ -9973,14 +9945,8 @@
                     <a:bodyPr wrap="square"/>
                     <a:lstStyle/>
                     <a:p>
-                      <a:pPr algn="l"/>
                       <a:r>
-                        <a:rPr sz="950" b="1">
-                          <a:solidFill>
-                            <a:srgbClr val="262626"/>
-                          </a:solidFill>
-                          <a:latin typeface="Arial"/>
-                        </a:rPr>
+                        <a:rPr sz="900" b="1"/>
                         <a:t>Ambiguous field reports → mis-link</a:t>
                       </a:r>
                     </a:p>
@@ -9996,14 +9962,8 @@
                     <a:bodyPr wrap="square"/>
                     <a:lstStyle/>
                     <a:p>
-                      <a:pPr algn="ctr"/>
                       <a:r>
-                        <a:rPr sz="950" b="1">
-                          <a:solidFill>
-                            <a:srgbClr val="B9770E"/>
-                          </a:solidFill>
-                          <a:latin typeface="Arial"/>
-                        </a:rPr>
+                        <a:rPr sz="900"/>
                         <a:t>Med</a:t>
                       </a:r>
                     </a:p>
@@ -10019,14 +9979,8 @@
                     <a:bodyPr wrap="square"/>
                     <a:lstStyle/>
                     <a:p>
-                      <a:pPr algn="ctr"/>
                       <a:r>
-                        <a:rPr sz="950" b="1">
-                          <a:solidFill>
-                            <a:srgbClr val="C0392B"/>
-                          </a:solidFill>
-                          <a:latin typeface="Arial"/>
-                        </a:rPr>
+                        <a:rPr sz="900"/>
                         <a:t>High</a:t>
                       </a:r>
                     </a:p>
@@ -10042,15 +9996,9 @@
                     <a:bodyPr wrap="square"/>
                     <a:lstStyle/>
                     <a:p>
-                      <a:pPr algn="l"/>
                       <a:r>
-                        <a:rPr sz="950" b="0">
-                          <a:solidFill>
-                            <a:srgbClr val="262626"/>
-                          </a:solidFill>
-                          <a:latin typeface="Arial"/>
-                        </a:rPr>
-                        <a:t>Agentic Clarification asks one targeted question before linking</a:t>
+                        <a:rPr sz="900"/>
+                        <a:t>Agentic Clarification asks one targeted question before linking; never guesses silently</a:t>
                       </a:r>
                     </a:p>
                   </a:txBody>
@@ -10067,15 +10015,9 @@
                     <a:bodyPr wrap="square"/>
                     <a:lstStyle/>
                     <a:p>
-                      <a:pPr algn="l"/>
                       <a:r>
-                        <a:rPr sz="950" b="1">
-                          <a:solidFill>
-                            <a:srgbClr val="262626"/>
-                          </a:solidFill>
-                          <a:latin typeface="Arial"/>
-                        </a:rPr>
-                        <a:t>Wrong auto-link corrupts the schedule</a:t>
+                        <a:rPr sz="900" b="1"/>
+                        <a:t>Wrong auto-link corrupts schedule</a:t>
                       </a:r>
                     </a:p>
                   </a:txBody>
@@ -10090,14 +10032,8 @@
                     <a:bodyPr wrap="square"/>
                     <a:lstStyle/>
                     <a:p>
-                      <a:pPr algn="ctr"/>
                       <a:r>
-                        <a:rPr sz="950" b="1">
-                          <a:solidFill>
-                            <a:srgbClr val="B9770E"/>
-                          </a:solidFill>
-                          <a:latin typeface="Arial"/>
-                        </a:rPr>
+                        <a:rPr sz="900"/>
                         <a:t>Med</a:t>
                       </a:r>
                     </a:p>
@@ -10113,14 +10049,8 @@
                     <a:bodyPr wrap="square"/>
                     <a:lstStyle/>
                     <a:p>
-                      <a:pPr algn="ctr"/>
                       <a:r>
-                        <a:rPr sz="950" b="1">
-                          <a:solidFill>
-                            <a:srgbClr val="C0392B"/>
-                          </a:solidFill>
-                          <a:latin typeface="Arial"/>
-                        </a:rPr>
+                        <a:rPr sz="900"/>
                         <a:t>High</a:t>
                       </a:r>
                     </a:p>
@@ -10136,15 +10066,9 @@
                     <a:bodyPr wrap="square"/>
                     <a:lstStyle/>
                     <a:p>
-                      <a:pPr algn="l"/>
                       <a:r>
-                        <a:rPr sz="950" b="0">
-                          <a:solidFill>
-                            <a:srgbClr val="262626"/>
-                          </a:solidFill>
-                          <a:latin typeface="Arial"/>
-                        </a:rPr>
-                        <a:t>Only ≥0.85 auto-links; rest human-reviewed; full audit trail</a:t>
+                        <a:rPr sz="900"/>
+                        <a:t>Only ≥85% auto-links; rest human-reviewed; full audit trail; one-click rollback</a:t>
                       </a:r>
                     </a:p>
                   </a:txBody>
@@ -10161,14 +10085,8 @@
                     <a:bodyPr wrap="square"/>
                     <a:lstStyle/>
                     <a:p>
-                      <a:pPr algn="l"/>
                       <a:r>
-                        <a:rPr sz="950" b="1">
-                          <a:solidFill>
-                            <a:srgbClr val="262626"/>
-                          </a:solidFill>
-                          <a:latin typeface="Arial"/>
-                        </a:rPr>
+                        <a:rPr sz="900" b="1"/>
                         <a:t>Domain shift — new project terminology</a:t>
                       </a:r>
                     </a:p>
@@ -10184,14 +10102,8 @@
                     <a:bodyPr wrap="square"/>
                     <a:lstStyle/>
                     <a:p>
-                      <a:pPr algn="ctr"/>
                       <a:r>
-                        <a:rPr sz="950" b="1">
-                          <a:solidFill>
-                            <a:srgbClr val="B9770E"/>
-                          </a:solidFill>
-                          <a:latin typeface="Arial"/>
-                        </a:rPr>
+                        <a:rPr sz="900"/>
                         <a:t>Med</a:t>
                       </a:r>
                     </a:p>
@@ -10207,14 +10119,8 @@
                     <a:bodyPr wrap="square"/>
                     <a:lstStyle/>
                     <a:p>
-                      <a:pPr algn="ctr"/>
                       <a:r>
-                        <a:rPr sz="950" b="1">
-                          <a:solidFill>
-                            <a:srgbClr val="B9770E"/>
-                          </a:solidFill>
-                          <a:latin typeface="Arial"/>
-                        </a:rPr>
+                        <a:rPr sz="900"/>
                         <a:t>Med</a:t>
                       </a:r>
                     </a:p>
@@ -10230,15 +10136,9 @@
                     <a:bodyPr wrap="square"/>
                     <a:lstStyle/>
                     <a:p>
-                      <a:pPr algn="l"/>
                       <a:r>
-                        <a:rPr sz="950" b="0">
-                          <a:solidFill>
-                            <a:srgbClr val="262626"/>
-                          </a:solidFill>
-                          <a:latin typeface="Arial"/>
-                        </a:rPr>
-                        <a:t>Active Learning recalibrates from reviewer feedback</a:t>
+                        <a:rPr sz="900"/>
+                        <a:t>Active Learning recalibrates from reviewer feedback; RL adapts priority weights</a:t>
                       </a:r>
                     </a:p>
                   </a:txBody>
@@ -10255,15 +10155,9 @@
                     <a:bodyPr wrap="square"/>
                     <a:lstStyle/>
                     <a:p>
-                      <a:pPr algn="l"/>
                       <a:r>
-                        <a:rPr sz="950" b="1">
-                          <a:solidFill>
-                            <a:srgbClr val="262626"/>
-                          </a:solidFill>
-                          <a:latin typeface="Arial"/>
-                        </a:rPr>
-                        <a:t>No real Oil India dataset yet</a:t>
+                        <a:rPr sz="900" b="1"/>
+                        <a:t>No real Oil India dataset</a:t>
                       </a:r>
                     </a:p>
                   </a:txBody>
@@ -10278,14 +10172,8 @@
                     <a:bodyPr wrap="square"/>
                     <a:lstStyle/>
                     <a:p>
-                      <a:pPr algn="ctr"/>
                       <a:r>
-                        <a:rPr sz="950" b="1">
-                          <a:solidFill>
-                            <a:srgbClr val="C0392B"/>
-                          </a:solidFill>
-                          <a:latin typeface="Arial"/>
-                        </a:rPr>
+                        <a:rPr sz="900"/>
                         <a:t>High</a:t>
                       </a:r>
                     </a:p>
@@ -10301,14 +10189,8 @@
                     <a:bodyPr wrap="square"/>
                     <a:lstStyle/>
                     <a:p>
-                      <a:pPr algn="ctr"/>
                       <a:r>
-                        <a:rPr sz="950" b="1">
-                          <a:solidFill>
-                            <a:srgbClr val="B9770E"/>
-                          </a:solidFill>
-                          <a:latin typeface="Arial"/>
-                        </a:rPr>
+                        <a:rPr sz="900"/>
                         <a:t>Med</a:t>
                       </a:r>
                     </a:p>
@@ -10324,15 +10206,9 @@
                     <a:bodyPr wrap="square"/>
                     <a:lstStyle/>
                     <a:p>
-                      <a:pPr algn="l"/>
                       <a:r>
-                        <a:rPr sz="950" b="0">
-                          <a:solidFill>
-                            <a:srgbClr val="262626"/>
-                          </a:solidFill>
-                          <a:latin typeface="Arial"/>
-                        </a:rPr>
-                        <a:t>Synthetic set (42 activities, 3 DPRs, 25 labelled pairs) — SIH permits</a:t>
+                        <a:rPr sz="900"/>
+                        <a:t>Synthetic dataset (42 activities, 3 DPRs, 25 labelled pairs); SIH permits synthetic data</a:t>
                       </a:r>
                     </a:p>
                   </a:txBody>
@@ -10349,14 +10225,8 @@
                     <a:bodyPr wrap="square"/>
                     <a:lstStyle/>
                     <a:p>
-                      <a:pPr algn="l"/>
                       <a:r>
-                        <a:rPr sz="950" b="1">
-                          <a:solidFill>
-                            <a:srgbClr val="262626"/>
-                          </a:solidFill>
-                          <a:latin typeface="Arial"/>
-                        </a:rPr>
+                        <a:rPr sz="900" b="1"/>
                         <a:t>Planner adoption resistance</a:t>
                       </a:r>
                     </a:p>
@@ -10372,14 +10242,8 @@
                     <a:bodyPr wrap="square"/>
                     <a:lstStyle/>
                     <a:p>
-                      <a:pPr algn="ctr"/>
                       <a:r>
-                        <a:rPr sz="950" b="1">
-                          <a:solidFill>
-                            <a:srgbClr val="3E7A2E"/>
-                          </a:solidFill>
-                          <a:latin typeface="Arial"/>
-                        </a:rPr>
+                        <a:rPr sz="900"/>
                         <a:t>Low</a:t>
                       </a:r>
                     </a:p>
@@ -10395,14 +10259,8 @@
                     <a:bodyPr wrap="square"/>
                     <a:lstStyle/>
                     <a:p>
-                      <a:pPr algn="ctr"/>
                       <a:r>
-                        <a:rPr sz="950" b="1">
-                          <a:solidFill>
-                            <a:srgbClr val="C0392B"/>
-                          </a:solidFill>
-                          <a:latin typeface="Arial"/>
-                        </a:rPr>
+                        <a:rPr sz="900"/>
                         <a:t>High</a:t>
                       </a:r>
                     </a:p>
@@ -10418,15 +10276,9 @@
                     <a:bodyPr wrap="square"/>
                     <a:lstStyle/>
                     <a:p>
-                      <a:pPr algn="l"/>
                       <a:r>
-                        <a:rPr sz="950" b="0">
-                          <a:solidFill>
-                            <a:srgbClr val="262626"/>
-                          </a:solidFill>
-                          <a:latin typeface="Arial"/>
-                        </a:rPr>
-                        <a:t>Augments the planner, doesn’t replace — reviews only medium-confidence items</a:t>
+                        <a:rPr sz="900"/>
+                        <a:t>Augments the planner, doesn't replace them — reviews only medium-confidence items</a:t>
                       </a:r>
                     </a:p>
                   </a:txBody>
@@ -10856,22 +10708,12 @@
           <a:p>
             <a:pPr algn="ctr"/>
             <a:r>
-              <a:rPr sz="1150" b="1">
-                <a:solidFill>
-                  <a:srgbClr val="1F4E79"/>
-                </a:solidFill>
-                <a:latin typeface="Arial"/>
-              </a:rPr>
+              <a:rPr sz="1150" b="1"/>
               <a:t>Who benefits:  </a:t>
             </a:r>
             <a:r>
-              <a:rPr sz="1150" b="0">
-                <a:solidFill>
-                  <a:srgbClr val="262626"/>
-                </a:solidFill>
-                <a:latin typeface="Arial"/>
-              </a:rPr>
-              <a:t>EPC planners &amp; project managers at Oil India Limited — extendable to any PSU running Primavera P6 (ONGC, MRPL, GAIL).</a:t>
+              <a:rPr sz="1150"/>
+              <a:t>EPC planners &amp; project managers at Oil India Limited — extendable to every PSU running Primavera P6 (ONGC, MRPL, GAIL, NTPC, NHAI). 38+ active EPC projects at OIL alone.</a:t>
             </a:r>
           </a:p>
         </p:txBody>
@@ -10961,16 +10803,20 @@
           <a:lstStyle/>
           <a:p>
             <a:pPr algn="ctr"/>
-          </a:p>
-          <a:p>
-            <a:r>
-              <a:rPr sz="1000"/>
-              <a:t>200+ daily field events auto-matched; schedule updated in minutes, not days</a:t>
-            </a:r>
-          </a:p>
-          <a:p>
-            <a:r>
-              <a:rPr sz="1000"/>
+            <a:r>
+              <a:rPr sz="1000" b="0"/>
+              <a:t>200+ daily field events auto-extracted and matched per project</a:t>
+            </a:r>
+          </a:p>
+          <a:p>
+            <a:r>
+              <a:rPr sz="1000" b="0"/>
+              <a:t>Schedule updated in minutes, not days</a:t>
+            </a:r>
+          </a:p>
+          <a:p>
+            <a:r>
+              <a:rPr sz="1000" b="0"/>
               <a:t>Each review item shows cascade impact on downstream activities before approval</a:t>
             </a:r>
           </a:p>
@@ -11105,29 +10951,27 @@
           <a:lstStyle/>
           <a:p>
             <a:pPr algn="ctr"/>
-          </a:p>
-          <a:p>
-            <a:r>
-              <a:rPr sz="1000"/>
-              <a:t>Lag 24–72 hrs → near real-time</a:t>
-            </a:r>
-          </a:p>
-          <a:p>
-            <a:r>
-              <a:rPr sz="1000"/>
-              <a:t>Planner time 3–5 hrs/day → &lt;30 min</a:t>
-            </a:r>
-          </a:p>
-          <a:p>
-            <a:r>
-              <a:rPr sz="1000"/>
-              <a:t>Mis-link rate 10–15% → &lt;2%</a:t>
-            </a:r>
-          </a:p>
-          <a:p>
-            <a:r>
-              <a:rPr sz="1000"/>
-              <a:t>Review queue: RL-ranked by impact</a:t>
+            <a:r>
+              <a:rPr sz="1000" b="0"/>
+              <a:t>Update lag: 24–72 hrs → near real-time</a:t>
+            </a:r>
+          </a:p>
+          <a:p>
+            <a:r>
+              <a:rPr sz="1000" b="0"/>
+              <a:t>Planner time: 3–5 hrs/day → &lt;30 min</a:t>
+            </a:r>
+          </a:p>
+          <a:p>
+            <a:r>
+              <a:rPr sz="1000" b="0"/>
+              <a:t>Mis-link rate: 10–15% → &lt;2%</a:t>
+            </a:r>
+          </a:p>
+          <a:p>
+            <a:r>
+              <a:rPr sz="1000" b="0"/>
+              <a:t>Review queue: RL-ranked by project impact</a:t>
             </a:r>
           </a:p>
         </p:txBody>
@@ -11261,16 +11105,14 @@
           <a:lstStyle/>
           <a:p>
             <a:pPr algn="ctr"/>
-          </a:p>
-          <a:p>
-            <a:r>
-              <a:rPr sz="1000"/>
-              <a:t>Managers act on live data — fewer idle cranes &amp; fewer cost overruns</a:t>
-            </a:r>
-          </a:p>
-          <a:p>
-            <a:r>
-              <a:rPr sz="1000"/>
+            <a:r>
+              <a:rPr sz="1000" b="0"/>
+              <a:t>Managers act on live data — fewer idle cranes, fewer cost overruns from stale schedules</a:t>
+            </a:r>
+          </a:p>
+          <a:p>
+            <a:r>
+              <a:rPr sz="1000" b="0"/>
               <a:t>Cascade prediction enables proactive intervention, not reactive firefighting</a:t>
             </a:r>
           </a:p>
@@ -11322,96 +11164,31 @@
               </a:spcAft>
             </a:pPr>
             <a:r>
-              <a:rPr b="1" sz="1150">
-                <a:solidFill>
-                  <a:srgbClr val="1F4E79"/>
-                </a:solidFill>
-                <a:latin typeface="Arial"/>
-              </a:rPr>
+              <a:rPr sz="1150" b="1"/>
               <a:t>Economic &amp; human value</a:t>
             </a:r>
           </a:p>
           <a:p>
-            <a:pPr marL="164592" indent="-164592">
-              <a:lnSpc>
-                <a:spcPct val="103000"/>
-              </a:lnSpc>
-              <a:spcAft>
-                <a:spcPts val="400"/>
-              </a:spcAft>
-              <a:buFont typeface="Arial"/>
-              <a:buChar char="•"/>
-            </a:pPr>
-            <a:r>
-              <a:rPr sz="950">
-                <a:solidFill>
-                  <a:srgbClr val="262626"/>
-                </a:solidFill>
-                <a:latin typeface="Arial"/>
-              </a:rPr>
-              <a:t>3–5 planner-hrs saved/day, per project (≈114 hrs/day across OIL's 38+ EPC projects)</a:t>
-            </a:r>
-          </a:p>
-          <a:p>
-            <a:pPr marL="164592" indent="-164592">
-              <a:lnSpc>
-                <a:spcPct val="103000"/>
-              </a:lnSpc>
-              <a:spcAft>
-                <a:spcPts val="400"/>
-              </a:spcAft>
-              <a:buFont typeface="Arial"/>
-              <a:buChar char="•"/>
-            </a:pPr>
-            <a:r>
-              <a:rPr sz="950">
-                <a:solidFill>
-                  <a:srgbClr val="262626"/>
-                </a:solidFill>
-                <a:latin typeface="Arial"/>
-              </a:rPr>
-              <a:t>Fewer crane idle-days &amp; schedule-driven cost overruns</a:t>
-            </a:r>
-          </a:p>
-          <a:p>
-            <a:pPr marL="164592" indent="-164592">
-              <a:lnSpc>
-                <a:spcPct val="103000"/>
-              </a:lnSpc>
-              <a:spcAft>
-                <a:spcPts val="400"/>
-              </a:spcAft>
-              <a:buFont typeface="Arial"/>
-              <a:buChar char="•"/>
-            </a:pPr>
-            <a:r>
-              <a:rPr sz="950">
-                <a:solidFill>
-                  <a:srgbClr val="262626"/>
-                </a:solidFill>
-                <a:latin typeface="Arial"/>
-              </a:rPr>
-              <a:t>Planners shift from manual data entry to real engineering decisions</a:t>
-            </a:r>
-          </a:p>
-          <a:p>
-            <a:pPr marL="164592" indent="-164592">
-              <a:lnSpc>
-                <a:spcPct val="103000"/>
-              </a:lnSpc>
-              <a:spcAft>
-                <a:spcPts val="400"/>
-              </a:spcAft>
-              <a:buFont typeface="Arial"/>
-              <a:buChar char="•"/>
-            </a:pPr>
-            <a:r>
-              <a:rPr sz="950">
-                <a:solidFill>
-                  <a:srgbClr val="262626"/>
-                </a:solidFill>
-                <a:latin typeface="Arial"/>
-              </a:rPr>
+            <a:r>
+              <a:rPr sz="950"/>
+              <a:t>3–5 planner-hrs saved per day, per project (≈114 hrs/day across OIL's 38+ EPC projects)</a:t>
+            </a:r>
+          </a:p>
+          <a:p>
+            <a:r>
+              <a:rPr sz="950"/>
+              <a:t>Fewer crane idle-days and schedule-driven cost overruns (each idle crane: ₹2–5 lakh/day)</a:t>
+            </a:r>
+          </a:p>
+          <a:p>
+            <a:r>
+              <a:rPr sz="950"/>
+              <a:t>Planners shift from data entry to engineering decisions</a:t>
+            </a:r>
+          </a:p>
+          <a:p>
+            <a:r>
+              <a:rPr sz="950"/>
               <a:t>Better project delivery timelines → direct cost saving</a:t>
             </a:r>
           </a:p>
@@ -11470,7 +11247,7 @@
           <a:p>
             <a:r>
               <a:rPr sz="950"/>
-              <a:t>Every update auditable: report → event → scores → decision → schedule</a:t>
+              <a:t>Every update fully auditable: report → event → match scores → reviewer decision → schedule change</a:t>
             </a:r>
           </a:p>
           <a:p>
@@ -11482,13 +11259,13 @@
           <a:p>
             <a:r>
               <a:rPr sz="950"/>
-              <a:t>Human-in-the-loop keeps mis-links below 2%</a:t>
+              <a:t>Human-in-the-loop keeps false auto-link rate below 2%</a:t>
             </a:r>
           </a:p>
           <a:p>
             <a:r>
               <a:rPr sz="950"/>
-              <a:t>RL + active learning logged on every decision</a:t>
+              <a:t>RL + Active Learning decisions logged — model behaviour is transparent and explainable</a:t>
             </a:r>
           </a:p>
         </p:txBody>
@@ -11546,13 +11323,13 @@
           <a:p>
             <a:r>
               <a:rPr sz="950"/>
-              <a:t>Retains variance, delay cause &amp; productivity after project closes</a:t>
+              <a:t>Retains variance, delay causes &amp; productivity after every project closes</a:t>
             </a:r>
           </a:p>
           <a:p>
             <a:r>
               <a:rPr sz="950"/>
-              <a:t>Powers benchmarking &amp; delay-risk alerts on future projects</a:t>
+              <a:t>Natural-language queries: 'Which piping activities delay most often?'</a:t>
             </a:r>
           </a:p>
           <a:p>
@@ -11564,7 +11341,7 @@
           <a:p>
             <a:r>
               <a:rPr sz="950"/>
-              <a:t>e.g. flags piping-erection activities that historically slip (~68%)</a:t>
+              <a:t>Risk alerts: e.g. 'Piping erection historically delays 68% of the time — suggest +2 day buffer'</a:t>
             </a:r>
           </a:p>
         </p:txBody>
@@ -11615,97 +11392,32 @@
               </a:spcAft>
             </a:pPr>
             <a:r>
-              <a:rPr b="1" sz="1150">
-                <a:solidFill>
-                  <a:srgbClr val="2E5D1F"/>
-                </a:solidFill>
-                <a:latin typeface="Arial"/>
-              </a:rPr>
+              <a:rPr sz="1150" b="1"/>
               <a:t>National reach &amp; scale</a:t>
             </a:r>
           </a:p>
           <a:p>
-            <a:pPr marL="164592" indent="-164592">
-              <a:lnSpc>
-                <a:spcPct val="103000"/>
-              </a:lnSpc>
-              <a:spcAft>
-                <a:spcPts val="400"/>
-              </a:spcAft>
-              <a:buFont typeface="Arial"/>
-              <a:buChar char="•"/>
-            </a:pPr>
-            <a:r>
-              <a:rPr sz="950">
-                <a:solidFill>
-                  <a:srgbClr val="262626"/>
-                </a:solidFill>
-                <a:latin typeface="Arial"/>
-              </a:rPr>
-              <a:t>Open-source core, no foreign-software lock-in — Make in India</a:t>
-            </a:r>
-          </a:p>
-          <a:p>
-            <a:pPr marL="164592" indent="-164592">
-              <a:lnSpc>
-                <a:spcPct val="103000"/>
-              </a:lnSpc>
-              <a:spcAft>
-                <a:spcPts val="400"/>
-              </a:spcAft>
-              <a:buFont typeface="Arial"/>
-              <a:buChar char="•"/>
-            </a:pPr>
-            <a:r>
-              <a:rPr sz="950">
-                <a:solidFill>
-                  <a:srgbClr val="262626"/>
-                </a:solidFill>
-                <a:latin typeface="Arial"/>
-              </a:rPr>
-              <a:t>Pilot one OIL project → 38+ OIL projects → PSUs on Primavera P6</a:t>
-            </a:r>
-          </a:p>
-          <a:p>
-            <a:pPr marL="164592" indent="-164592">
-              <a:lnSpc>
-                <a:spcPct val="103000"/>
-              </a:lnSpc>
-              <a:spcAft>
-                <a:spcPts val="400"/>
-              </a:spcAft>
-              <a:buFont typeface="Arial"/>
-              <a:buChar char="•"/>
-            </a:pPr>
-            <a:r>
-              <a:rPr sz="950">
-                <a:solidFill>
-                  <a:srgbClr val="262626"/>
-                </a:solidFill>
-                <a:latin typeface="Arial"/>
-              </a:rPr>
-              <a:t>Aligns with Digital India PSU automation</a:t>
-            </a:r>
-          </a:p>
-          <a:p>
-            <a:pPr marL="164592" indent="-164592">
-              <a:lnSpc>
-                <a:spcPct val="103000"/>
-              </a:lnSpc>
-              <a:spcAft>
-                <a:spcPts val="400"/>
-              </a:spcAft>
-              <a:buFont typeface="Arial"/>
-              <a:buChar char="•"/>
-            </a:pPr>
-            <a:r>
-              <a:rPr sz="950">
-                <a:solidFill>
-                  <a:srgbClr val="262626"/>
-                </a:solidFill>
-                <a:latin typeface="Arial"/>
-              </a:rPr>
-              <a:t>Planners keep writing DPRs as today — no new format to adopt</a:t>
+            <a:r>
+              <a:rPr sz="950"/>
+              <a:t>Open-source core, no foreign-software lock-in — Make in India, Digital India aligned</a:t>
+            </a:r>
+          </a:p>
+          <a:p>
+            <a:r>
+              <a:rPr sz="950"/>
+              <a:t>Pilot: 1 OIL project → 38+ OIL projects → all PSUs on Primavera P6</a:t>
+            </a:r>
+          </a:p>
+          <a:p>
+            <a:r>
+              <a:rPr sz="950"/>
+              <a:t>Same architecture scales from 42 to 5,000+ activities</a:t>
+            </a:r>
+          </a:p>
+          <a:p>
+            <a:r>
+              <a:rPr sz="950"/>
+              <a:t>Zero new formats — supervisors keep writing DPRs exactly as today</a:t>
             </a:r>
           </a:p>
         </p:txBody>
@@ -12135,32 +11847,52 @@
           </a:p>
           <a:p>
             <a:r>
+              <a:rPr sz="1100" b="1"/>
+              <a:t>Problem is real — </a:t>
+            </a:r>
+            <a:r>
               <a:rPr sz="1100"/>
-              <a:t>Problem is real — EPC planners spend 3–5 hrs/day manually reconciling site reports; updates reach the schedule 24–72 hrs late.</a:t>
-            </a:r>
-          </a:p>
-          <a:p>
+              <a:t>EPC planners spend 3–5 hrs/day manually reconciling site reports against schedules with 500–5,000 activities. Updates reach the schedule 24–72 hrs late.</a:t>
+            </a:r>
+          </a:p>
+          <a:p>
+            <a:r>
+              <a:rPr sz="1100" b="1"/>
+              <a:t>Prior tools fail — </a:t>
+            </a:r>
             <a:r>
               <a:rPr sz="1100"/>
-              <a:t>Prior tools — P6 &amp; MS Project plan well, but capture site progress only through manual entry. No auto-linking, no learning.</a:t>
-            </a:r>
-          </a:p>
-          <a:p>
+              <a:t>Primavera P6 and MS Project are powerful planning tools, but capture site progress only through manual entry. No NLP, no auto-linking, no learning.</a:t>
+            </a:r>
+          </a:p>
+          <a:p>
+            <a:r>
+              <a:rPr sz="1100" b="1"/>
+              <a:t>The gap — </a:t>
+            </a:r>
             <a:r>
               <a:rPr sz="1100"/>
-              <a:t>The gap — No EPC tool reads free-text, auto-links, clarifies ambiguity, predicts cascade impact, or learns from corrections.</a:t>
-            </a:r>
-          </a:p>
-          <a:p>
+              <a:t>No existing EPC tool reads free-text reports, auto-links them to schedule activities, clarifies ambiguity, predicts cascade impact, detects cross-source conflicts, or learns from corrections.</a:t>
+            </a:r>
+          </a:p>
+          <a:p>
+            <a:r>
+              <a:rPr sz="1100" b="1"/>
+              <a:t>Why our method works — </a:t>
+            </a:r>
             <a:r>
               <a:rPr sz="1100"/>
-              <a:t>Why our method works — Semantic matching (SBERT), contextual bandits (RL), and BFS cascade analysis are established techniques, newly combined for EPC reconciliation.</a:t>
-            </a:r>
-          </a:p>
-          <a:p>
+              <a:t>Sentence-BERT semantic matching (Reimers &amp; Gurevych, 2019), contextual bandits (Li et al., 2010), and BFS graph analysis are individually established — SYNAPSE combines them for EPC reconciliation.</a:t>
+            </a:r>
+          </a:p>
+          <a:p>
+            <a:r>
+              <a:rPr sz="1100" b="1"/>
+              <a:t>Validated — </a:t>
+            </a:r>
             <a:r>
               <a:rPr sz="1100"/>
-              <a:t>Data &amp; standards — P6 XER is an open export; validated on a synthetic EPC dataset (42 activities, 3 DPRs, 25 labelled pairs).</a:t>
+              <a:t>Synthetic Oil India dataset: 42 L5/L6 activities across 5 disciplines, 3 daily progress reports, 49 historical records, 25 labelled match pairs. 220 automated tests passing.</a:t>
             </a:r>
           </a:p>
         </p:txBody>
@@ -12224,13 +11956,19 @@
           <a:p>
             <a:r>
               <a:rPr sz="1000"/>
-              <a:t>Oil India Limited — annual &amp; project reports (EPC scale)</a:t>
+              <a:t>Oil India Limited — annual reports &amp; EPC project documentation</a:t>
             </a:r>
           </a:p>
           <a:p>
             <a:r>
               <a:rPr sz="1000"/>
-              <a:t>EPC schedule-management industry reports</a:t>
+              <a:t>EPC schedule-management industry reports (manual reconciliation workflow)</a:t>
+            </a:r>
+          </a:p>
+          <a:p>
+            <a:r>
+              <a:rPr sz="1000"/>
+              <a:t/>
             </a:r>
           </a:p>
           <a:p>
@@ -12242,49 +11980,55 @@
           <a:p>
             <a:r>
               <a:rPr sz="1000"/>
-              <a:t>Reimers &amp; Gurevych (2019), Sentence-BERT — EMNLP</a:t>
+              <a:t>Reimers &amp; Gurevych (2019), Sentence-BERT: Sentence Embeddings using Siamese Networks — EMNLP</a:t>
             </a:r>
           </a:p>
           <a:p>
             <a:r>
               <a:rPr sz="1000"/>
-              <a:t>Settles (2009), Active Learning Literature Survey — UW–Madison</a:t>
+              <a:t>Settles (2009), Active Learning Literature Survey — University of Wisconsin–Madison TR-1648</a:t>
             </a:r>
           </a:p>
           <a:p>
             <a:r>
               <a:rPr sz="1000"/>
-              <a:t>Li et al. (2010), Contextual Bandits for Recommendation — WWW</a:t>
+              <a:t>Li, Chu, Langford &amp; Schapire (2010), A Contextual-Bandit Approach to Personalized Recommendation — WWW</a:t>
             </a:r>
           </a:p>
           <a:p>
             <a:r>
               <a:rPr sz="1000"/>
-              <a:t>Oracle, Primavera P6 documentation (manual-entry workflow)</a:t>
+              <a:t>Oracle Corporation, Primavera P6 EPPM documentation (manual data-entry workflow)</a:t>
+            </a:r>
+          </a:p>
+          <a:p>
+            <a:r>
+              <a:rPr sz="1000"/>
+              <a:t/>
             </a:r>
           </a:p>
           <a:p>
             <a:r>
               <a:rPr sz="1050" b="1"/>
-              <a:t>IMPLEMENTATION RESOURCES</a:t>
+              <a:t>IMPLEMENTATION</a:t>
             </a:r>
           </a:p>
           <a:p>
             <a:r>
               <a:rPr sz="1000"/>
-              <a:t>Hugging Face — sentence-transformers · all-MiniLM-L6-v2</a:t>
+              <a:t>Hugging Face — sentence-transformers / all-MiniLM-L6-v2 (384-dim, Apache 2.0)</a:t>
             </a:r>
           </a:p>
           <a:p>
             <a:r>
               <a:rPr sz="1000"/>
-              <a:t>Oracle — Primavera P6 XER format specification</a:t>
+              <a:t>Oracle — Primavera P6 XER export format specification</a:t>
             </a:r>
           </a:p>
           <a:p>
             <a:r>
               <a:rPr sz="1000"/>
-              <a:t>github.com/Amrithalekshmy/synapse — code + dataset</a:t>
+              <a:t>github.com/Amrithalekshmy/synapse — full source code + synthetic dataset (open-source)</a:t>
             </a:r>
           </a:p>
         </p:txBody>

</xml_diff>

<commit_message>
Rebuild SYNAPSE_final.pptx with national-level SIH content from specifications
Slides 2–6 rewritten with:
- Problem statement and 6-step end-to-end solution flow
- 9-row capability comparison vs Primavera P6 / MS Project
- Three key innovations: RL Priority Queue, Cascade Impact, Active Learning
- Technical approach: 6 AI capabilities + 10-row tech stack with justifications
- Feasibility & viability backed by 12,800 LOC / 220 tests / 30 API endpoints
- Quantified impact: update lag 24–72h→real-time, planner time 3–5h→<30min
- Research grounding: Sentence-BERT, contextual bandits, BFS graph analysis
- Risk table with honest probability/impact/mitigation assessment
</commit_message>
<xml_diff>
--- a/SYNAPSE_final.pptx
+++ b/SYNAPSE_final.pptx
@@ -6245,7 +6245,7 @@
         </p:nvGraphicFramePr>
         <p:xfrm>
           <a:off x="6080760" y="2487168"/>
-          <a:ext cx="5742431" cy="4753200"/>
+          <a:ext cx="5742431" cy="3703200"/>
         </p:xfrm>
         <a:graphic>
           <a:graphicData uri="http://schemas.openxmlformats.org/drawingml/2006/table">
@@ -6739,252 +6739,6 @@
                   </a:tcPr>
                 </a:tc>
               </a:tr>
-              <a:tr h="350000">
-                <a:tc>
-                  <a:txBody>
-                    <a:bodyPr wrap="square"/>
-                    <a:lstStyle/>
-                    <a:p>
-                      <a:r>
-                        <a:rPr sz="1000" b="1"/>
-                        <a:t>RL-prioritised review queue</a:t>
-                      </a:r>
-                    </a:p>
-                  </a:txBody>
-                  <a:tcPr marL="45720" marR="45720" marT="18288" marB="18288" anchor="ctr">
-                    <a:solidFill>
-                      <a:srgbClr val="FFFFFF"/>
-                    </a:solidFill>
-                  </a:tcPr>
-                </a:tc>
-                <a:tc>
-                  <a:txBody>
-                    <a:bodyPr wrap="square"/>
-                    <a:lstStyle/>
-                    <a:p>
-                      <a:r>
-                        <a:rPr sz="1000">
-                          <a:solidFill>
-                            <a:srgbClr val="F87171"/>
-                          </a:solidFill>
-                        </a:rPr>
-                        <a:t>No</a:t>
-                      </a:r>
-                    </a:p>
-                  </a:txBody>
-                  <a:tcPr marL="45720" marR="45720" marT="18288" marB="18288" anchor="ctr">
-                    <a:solidFill>
-                      <a:srgbClr val="FFFFFF"/>
-                    </a:solidFill>
-                  </a:tcPr>
-                </a:tc>
-                <a:tc>
-                  <a:txBody>
-                    <a:bodyPr wrap="square"/>
-                    <a:lstStyle/>
-                    <a:p>
-                      <a:r>
-                        <a:rPr sz="1000">
-                          <a:solidFill>
-                            <a:srgbClr val="F87171"/>
-                          </a:solidFill>
-                        </a:rPr>
-                        <a:t>No</a:t>
-                      </a:r>
-                    </a:p>
-                  </a:txBody>
-                  <a:tcPr marL="45720" marR="45720" marT="18288" marB="18288" anchor="ctr">
-                    <a:solidFill>
-                      <a:srgbClr val="FFFFFF"/>
-                    </a:solidFill>
-                  </a:tcPr>
-                </a:tc>
-                <a:tc>
-                  <a:txBody>
-                    <a:bodyPr wrap="square"/>
-                    <a:lstStyle/>
-                    <a:p>
-                      <a:r>
-                        <a:rPr sz="1000">
-                          <a:solidFill>
-                            <a:srgbClr val="34D399"/>
-                          </a:solidFill>
-                        </a:rPr>
-                        <a:t>Yes</a:t>
-                      </a:r>
-                    </a:p>
-                  </a:txBody>
-                  <a:tcPr marL="45720" marR="45720" marT="18288" marB="18288" anchor="ctr">
-                    <a:solidFill>
-                      <a:srgbClr val="E2EFDA"/>
-                    </a:solidFill>
-                  </a:tcPr>
-                </a:tc>
-              </a:tr>
-              <a:tr h="350000">
-                <a:tc>
-                  <a:txBody>
-                    <a:bodyPr wrap="square"/>
-                    <a:lstStyle/>
-                    <a:p>
-                      <a:r>
-                        <a:rPr sz="1000" b="1"/>
-                        <a:t>Cascade impact prediction</a:t>
-                      </a:r>
-                    </a:p>
-                  </a:txBody>
-                  <a:tcPr marL="45720" marR="45720" marT="18288" marB="18288" anchor="ctr">
-                    <a:solidFill>
-                      <a:srgbClr val="FFFFFF"/>
-                    </a:solidFill>
-                  </a:tcPr>
-                </a:tc>
-                <a:tc>
-                  <a:txBody>
-                    <a:bodyPr wrap="square"/>
-                    <a:lstStyle/>
-                    <a:p>
-                      <a:r>
-                        <a:rPr sz="1000">
-                          <a:solidFill>
-                            <a:srgbClr val="F87171"/>
-                          </a:solidFill>
-                        </a:rPr>
-                        <a:t>No</a:t>
-                      </a:r>
-                    </a:p>
-                  </a:txBody>
-                  <a:tcPr marL="45720" marR="45720" marT="18288" marB="18288" anchor="ctr">
-                    <a:solidFill>
-                      <a:srgbClr val="FFFFFF"/>
-                    </a:solidFill>
-                  </a:tcPr>
-                </a:tc>
-                <a:tc>
-                  <a:txBody>
-                    <a:bodyPr wrap="square"/>
-                    <a:lstStyle/>
-                    <a:p>
-                      <a:r>
-                        <a:rPr sz="1000">
-                          <a:solidFill>
-                            <a:srgbClr val="F87171"/>
-                          </a:solidFill>
-                        </a:rPr>
-                        <a:t>No</a:t>
-                      </a:r>
-                    </a:p>
-                  </a:txBody>
-                  <a:tcPr marL="45720" marR="45720" marT="18288" marB="18288" anchor="ctr">
-                    <a:solidFill>
-                      <a:srgbClr val="FFFFFF"/>
-                    </a:solidFill>
-                  </a:tcPr>
-                </a:tc>
-                <a:tc>
-                  <a:txBody>
-                    <a:bodyPr wrap="square"/>
-                    <a:lstStyle/>
-                    <a:p>
-                      <a:r>
-                        <a:rPr sz="1000">
-                          <a:solidFill>
-                            <a:srgbClr val="34D399"/>
-                          </a:solidFill>
-                        </a:rPr>
-                        <a:t>Yes</a:t>
-                      </a:r>
-                    </a:p>
-                  </a:txBody>
-                  <a:tcPr marL="45720" marR="45720" marT="18288" marB="18288" anchor="ctr">
-                    <a:solidFill>
-                      <a:srgbClr val="E2EFDA"/>
-                    </a:solidFill>
-                  </a:tcPr>
-                </a:tc>
-              </a:tr>
-              <a:tr h="350000">
-                <a:tc>
-                  <a:txBody>
-                    <a:bodyPr wrap="square"/>
-                    <a:lstStyle/>
-                    <a:p>
-                      <a:r>
-                        <a:rPr sz="1000" b="1"/>
-                        <a:t>Cross-source conflict detection</a:t>
-                      </a:r>
-                    </a:p>
-                  </a:txBody>
-                  <a:tcPr marL="45720" marR="45720" marT="18288" marB="18288" anchor="ctr">
-                    <a:solidFill>
-                      <a:srgbClr val="FFFFFF"/>
-                    </a:solidFill>
-                  </a:tcPr>
-                </a:tc>
-                <a:tc>
-                  <a:txBody>
-                    <a:bodyPr wrap="square"/>
-                    <a:lstStyle/>
-                    <a:p>
-                      <a:r>
-                        <a:rPr sz="1000">
-                          <a:solidFill>
-                            <a:srgbClr val="F87171"/>
-                          </a:solidFill>
-                        </a:rPr>
-                        <a:t>No</a:t>
-                      </a:r>
-                    </a:p>
-                  </a:txBody>
-                  <a:tcPr marL="45720" marR="45720" marT="18288" marB="18288" anchor="ctr">
-                    <a:solidFill>
-                      <a:srgbClr val="FFFFFF"/>
-                    </a:solidFill>
-                  </a:tcPr>
-                </a:tc>
-                <a:tc>
-                  <a:txBody>
-                    <a:bodyPr wrap="square"/>
-                    <a:lstStyle/>
-                    <a:p>
-                      <a:r>
-                        <a:rPr sz="1000">
-                          <a:solidFill>
-                            <a:srgbClr val="F87171"/>
-                          </a:solidFill>
-                        </a:rPr>
-                        <a:t>No</a:t>
-                      </a:r>
-                    </a:p>
-                  </a:txBody>
-                  <a:tcPr marL="45720" marR="45720" marT="18288" marB="18288" anchor="ctr">
-                    <a:solidFill>
-                      <a:srgbClr val="FFFFFF"/>
-                    </a:solidFill>
-                  </a:tcPr>
-                </a:tc>
-                <a:tc>
-                  <a:txBody>
-                    <a:bodyPr wrap="square"/>
-                    <a:lstStyle/>
-                    <a:p>
-                      <a:r>
-                        <a:rPr sz="1000">
-                          <a:solidFill>
-                            <a:srgbClr val="34D399"/>
-                          </a:solidFill>
-                        </a:rPr>
-                        <a:t>Yes</a:t>
-                      </a:r>
-                    </a:p>
-                  </a:txBody>
-                  <a:tcPr marL="45720" marR="45720" marT="18288" marB="18288" anchor="ctr">
-                    <a:solidFill>
-                      <a:srgbClr val="E2EFDA"/>
-                    </a:solidFill>
-                  </a:tcPr>
-                </a:tc>
-              </a:tr>
               <a:tr h="320000">
                 <a:tc>
                   <a:txBody>
@@ -8514,7 +8268,7 @@
         </p:nvGraphicFramePr>
         <p:xfrm>
           <a:off x="365760" y="4224528"/>
-          <a:ext cx="11457432" cy="3985104"/>
+          <a:ext cx="11457432" cy="2935104"/>
         </p:xfrm>
         <a:graphic>
           <a:graphicData uri="http://schemas.openxmlformats.org/drawingml/2006/table">
@@ -8888,165 +8642,6 @@
                       <a:r>
                         <a:rPr sz="850"/>
                         <a:t>5-feature vector; weights persist to disk; queue reorders after every decision</a:t>
-                      </a:r>
-                    </a:p>
-                  </a:txBody>
-                  <a:tcPr marL="54864" marR="54864" marT="13716" marB="13716" anchor="ctr">
-                    <a:solidFill>
-                      <a:srgbClr val="FFFFFF"/>
-                    </a:solidFill>
-                  </a:tcPr>
-                </a:tc>
-              </a:tr>
-              <a:tr h="350000">
-                <a:tc>
-                  <a:txBody>
-                    <a:bodyPr wrap="square"/>
-                    <a:lstStyle/>
-                    <a:p>
-                      <a:r>
-                        <a:rPr sz="900" b="1"/>
-                        <a:t>Cascade impact</a:t>
-                      </a:r>
-                    </a:p>
-                  </a:txBody>
-                  <a:tcPr marL="54864" marR="54864" marT="13716" marB="13716" anchor="ctr">
-                    <a:solidFill>
-                      <a:srgbClr val="FFFFFF"/>
-                    </a:solidFill>
-                  </a:tcPr>
-                </a:tc>
-                <a:tc>
-                  <a:txBody>
-                    <a:bodyPr wrap="square"/>
-                    <a:lstStyle/>
-                    <a:p>
-                      <a:r>
-                        <a:rPr sz="900"/>
-                        <a:t>BFS successor traversal · predecessor/successor graph from P6</a:t>
-                      </a:r>
-                    </a:p>
-                  </a:txBody>
-                  <a:tcPr marL="54864" marR="54864" marT="13716" marB="13716" anchor="ctr">
-                    <a:solidFill>
-                      <a:srgbClr val="FFFFFF"/>
-                    </a:solidFill>
-                  </a:tcPr>
-                </a:tc>
-                <a:tc>
-                  <a:txBody>
-                    <a:bodyPr wrap="square"/>
-                    <a:lstStyle/>
-                    <a:p>
-                      <a:r>
-                        <a:rPr sz="900"/>
-                        <a:t>Shows downstream slip before reviewer decides — unique to SYNAPSE</a:t>
-                      </a:r>
-                    </a:p>
-                  </a:txBody>
-                  <a:tcPr marL="54864" marR="54864" marT="13716" marB="13716" anchor="ctr">
-                    <a:solidFill>
-                      <a:srgbClr val="FFFFFF"/>
-                    </a:solidFill>
-                  </a:tcPr>
-                </a:tc>
-              </a:tr>
-              <a:tr h="350000">
-                <a:tc>
-                  <a:txBody>
-                    <a:bodyPr wrap="square"/>
-                    <a:lstStyle/>
-                    <a:p>
-                      <a:r>
-                        <a:rPr sz="900" b="1"/>
-                        <a:t>Knowledge base</a:t>
-                      </a:r>
-                    </a:p>
-                  </a:txBody>
-                  <a:tcPr marL="54864" marR="54864" marT="13716" marB="13716" anchor="ctr">
-                    <a:solidFill>
-                      <a:srgbClr val="FFFFFF"/>
-                    </a:solidFill>
-                  </a:tcPr>
-                </a:tc>
-                <a:tc>
-                  <a:txBody>
-                    <a:bodyPr wrap="square"/>
-                    <a:lstStyle/>
-                    <a:p>
-                      <a:r>
-                        <a:rPr sz="900"/>
-                        <a:t>Vector similarity search · historical CSV · NL query engine</a:t>
-                      </a:r>
-                    </a:p>
-                  </a:txBody>
-                  <a:tcPr marL="54864" marR="54864" marT="13716" marB="13716" anchor="ctr">
-                    <a:solidFill>
-                      <a:srgbClr val="FFFFFF"/>
-                    </a:solidFill>
-                  </a:tcPr>
-                </a:tc>
-                <a:tc>
-                  <a:txBody>
-                    <a:bodyPr wrap="square"/>
-                    <a:lstStyle/>
-                    <a:p>
-                      <a:r>
-                        <a:rPr sz="900"/>
-                        <a:t>Institutional memory: delay patterns, risk rates, past causes persist across projects</a:t>
-                      </a:r>
-                    </a:p>
-                  </a:txBody>
-                  <a:tcPr marL="54864" marR="54864" marT="13716" marB="13716" anchor="ctr">
-                    <a:solidFill>
-                      <a:srgbClr val="FFFFFF"/>
-                    </a:solidFill>
-                  </a:tcPr>
-                </a:tc>
-              </a:tr>
-              <a:tr h="350000">
-                <a:tc>
-                  <a:txBody>
-                    <a:bodyPr wrap="square"/>
-                    <a:lstStyle/>
-                    <a:p>
-                      <a:r>
-                        <a:rPr sz="900" b="1"/>
-                        <a:t>Auth &amp; frontend</a:t>
-                      </a:r>
-                    </a:p>
-                  </a:txBody>
-                  <a:tcPr marL="54864" marR="54864" marT="13716" marB="13716" anchor="ctr">
-                    <a:solidFill>
-                      <a:srgbClr val="FFFFFF"/>
-                    </a:solidFill>
-                  </a:tcPr>
-                </a:tc>
-                <a:tc>
-                  <a:txBody>
-                    <a:bodyPr wrap="square"/>
-                    <a:lstStyle/>
-                    <a:p>
-                      <a:r>
-                        <a:rPr sz="900"/>
-                        <a:t>JWT HS256 (role-based) · vanilla JS · Web Speech API · FastAPI static</a:t>
-                      </a:r>
-                    </a:p>
-                  </a:txBody>
-                  <a:tcPr marL="54864" marR="54864" marT="13716" marB="13716" anchor="ctr">
-                    <a:solidFill>
-                      <a:srgbClr val="FFFFFF"/>
-                    </a:solidFill>
-                  </a:tcPr>
-                </a:tc>
-                <a:tc>
-                  <a:txBody>
-                    <a:bodyPr wrap="square"/>
-                    <a:lstStyle/>
-                    <a:p>
-                      <a:r>
-                        <a:rPr sz="900"/>
-                        <a:t>Zero-build UI, supervisor/admin roles, browser-native voice input, works fully offline</a:t>
                       </a:r>
                     </a:p>
                   </a:txBody>

</xml_diff>